<commit_message>
Deployed df8ce49 with MkDocs version: 1.6.1
</commit_message>
<xml_diff>
--- a/files/beneath_the_mesa_slides.pptx
+++ b/files/beneath_the_mesa_slides.pptx
@@ -115,27 +115,27 @@
   <p:extLst>
     <p:ext uri="{521415D9-36F7-43E2-AB2F-B90AF26B5E84}">
       <p14:sectionLst xmlns:p14="http://schemas.microsoft.com/office/powerpoint/2010/main">
-        <p14:section name="Introduction" id="{089bf0c2-ab24-52a0-d839-1b07a86aeddc}">
+        <p14:section name="Introduction" id="{4101badc-8b7e-dbd4-f235-033b832cf91b}">
           <p14:sldIdLst>
             <p14:sldId id="256"/>
             <p14:sldId id="257"/>
             <p14:sldId id="258"/>
           </p14:sldIdLst>
         </p14:section>
-        <p14:section name="Data and methods" id="{21fc28f6-378f-7f30-0ac7-485e4a68b3c1}">
+        <p14:section name="Data and methods" id="{4046cb53-2e50-e541-221e-c7cb8c8f1490}">
           <p14:sldIdLst>
             <p14:sldId id="259"/>
             <p14:sldId id="260"/>
           </p14:sldIdLst>
         </p14:section>
-        <p14:section name="Results" id="{1786a194-ac3d-6101-b678-f5da2c18ddd2}">
+        <p14:section name="Results" id="{d260b7a3-657a-2a4b-f2bb-e38b6380e371}">
           <p14:sldIdLst>
             <p14:sldId id="261"/>
             <p14:sldId id="262"/>
             <p14:sldId id="263"/>
           </p14:sldIdLst>
         </p14:section>
-        <p14:section name="Wrap-up" id="{a55235ca-f605-374b-4e84-a6c03be59f96}">
+        <p14:section name="Wrap-up" id="{7db15c29-9bd4-735e-97be-23c010e2e091}">
           <p14:sldIdLst>
             <p14:sldId id="264"/>
           </p14:sldIdLst>
@@ -545,7 +545,8 @@
             <a:r>
               <a:rPr lang="en-US" dirty="0"/>
               <a:t>About 20 seconds. Introduce the project title and every team member by full name (the rubric requires full names on this slide).
-Timing guide for the 7-minute video: Title 0:20, Background 0:45, Research questions 0:40, Data 0:50, Methods 0:50, Results 1:30, Findings 1:00, Limitations 0:40, Links 0:25.</a:t>
+Timing guide for the 7-minute video: Title 0:20, Background 0:45, Research questions 0:40, Data 0:50, Methods 0:50, Results 1:30, Findings 1:00, Limitations 0:40, Links 0:25.
+The circle in the bottom-right corner is where the presenter's camera goes; keep charts and text out of that corner.</a:t>
             </a:r>
             <a:endParaRPr lang="en-US" dirty="0"/>
           </a:p>
@@ -633,7 +634,8 @@
           <a:p>
             <a:r>
               <a:rPr lang="en-US" dirty="0"/>
-              <a:t>About 45 seconds. Replace the bullets with your own points. Add a map: Insert &gt; Pictures, drop it over the dashed box, then delete the box.</a:t>
+              <a:t>About 45 seconds. Replace the bullets with your own points. Add a map: Insert &gt; Pictures, drop it over the dashed box, then delete the box.
+The circle in the bottom-right corner is where the presenter's camera goes; keep charts and text out of that corner.</a:t>
             </a:r>
             <a:endParaRPr lang="en-US" dirty="0"/>
           </a:p>
@@ -721,7 +723,8 @@
           <a:p>
             <a:r>
               <a:rPr lang="en-US" dirty="0"/>
-              <a:t>About 40 seconds. Pick the three questions the results actually answer. The full list of nine is in the proposal; rename the card headings if you pick different ones.</a:t>
+              <a:t>About 40 seconds. Pick the three questions the results actually answer. The full list of nine is in the proposal and on the app's home page; rename the row headings if you pick different ones.
+The circle in the bottom-right corner is where the presenter's camera goes; keep charts and text out of that corner.</a:t>
             </a:r>
             <a:endParaRPr lang="en-US" dirty="0"/>
           </a:p>
@@ -809,7 +812,8 @@
           <a:p>
             <a:r>
               <a:rPr lang="en-US" dirty="0"/>
-              <a:t>About 50 seconds. For each dataset: who published it, what it measures, the years covered, and how many wells or sites are in Sandoval County. Delete any card whose data the project didn't end up using.</a:t>
+              <a:t>About 50 seconds. For each dataset: who published it, what it measures, the years covered, and how many wells or sites are in Sandoval County. Delete any card whose data the project didn't end up using.
+The circle in the bottom-right corner is where the presenter's camera goes; keep charts and text out of that corner.</a:t>
             </a:r>
             <a:endParaRPr lang="en-US" dirty="0"/>
           </a:p>
@@ -897,7 +901,8 @@
           <a:p>
             <a:r>
               <a:rPr lang="en-US" dirty="0"/>
-              <a:t>About 50 seconds. One line per stage: where the data came from, how it was cleaned (see the Data cleaning page in the docs), what analysis was run, and what the Streamlit app shows.</a:t>
+              <a:t>About 50 seconds. One line per stage: where the data came from, how it was cleaned (see the Data cleaning page in the docs), what analysis was run, and what the Streamlit app shows.
+The circle in the bottom-right corner is where the presenter's camera goes; keep charts and text out of that corner.</a:t>
             </a:r>
             <a:endParaRPr lang="en-US" dirty="0"/>
           </a:p>
@@ -985,7 +990,8 @@
           <a:p>
             <a:r>
               <a:rPr lang="en-US" dirty="0"/>
-              <a:t>About 1 minute 30 seconds across all results slides. Duplicate this slide (right-click &gt; Duplicate Slide) for each chart. Rubric: the results slides must show graphs and screenshots of the outputs.</a:t>
+              <a:t>About 1 minute 30 seconds across all results slides. Duplicate this slide (right-click &gt; Duplicate Slide) for each chart. Rubric: the results slides must show graphs and screenshots of the outputs.
+The circle in the bottom-right corner is where the presenter's camera goes; keep charts and text out of that corner.</a:t>
             </a:r>
             <a:endParaRPr lang="en-US" dirty="0"/>
           </a:p>
@@ -1073,7 +1079,8 @@
           <a:p>
             <a:r>
               <a:rPr lang="en-US" dirty="0"/>
-              <a:t>About 1 minute. Keep the three levels of certainty separate. This is where to answer whether the data support the concern about Cuba's aquifer.</a:t>
+              <a:t>About 1 minute. Keep the three levels of certainty separate. The bottom line answers the main question from the research-questions slide.
+The circle in the bottom-right corner is where the presenter's camera goes; keep charts and text out of that corner.</a:t>
             </a:r>
             <a:endParaRPr lang="en-US" dirty="0"/>
           </a:p>
@@ -1161,7 +1168,8 @@
           <a:p>
             <a:r>
               <a:rPr lang="en-US" dirty="0"/>
-              <a:t>About 40 seconds. Name the data gaps and what the results can't support.</a:t>
+              <a:t>About 40 seconds. Name the data gaps and what the results can't support.
+The circle in the bottom-right corner is where the presenter's camera goes; keep charts and text out of that corner.</a:t>
             </a:r>
             <a:endParaRPr lang="en-US" dirty="0"/>
           </a:p>
@@ -1249,7 +1257,8 @@
           <a:p>
             <a:r>
               <a:rPr lang="en-US" dirty="0"/>
-              <a:t>About 25 seconds. Rubric: the final slide must link to the datasets, the GitHub repository, and the Streamlit app. Once Dylan adds the exact download pages to the Data collection docs page, add them here too.</a:t>
+              <a:t>About 25 seconds. Rubric: the final slide must link to the datasets, the GitHub repository, and the Streamlit app. Once Dylan adds the exact download pages to the Data collection docs page, add them here too.
+The circle in the bottom-right corner is where the presenter's camera goes; keep charts and text out of that corner.</a:t>
             </a:r>
             <a:endParaRPr lang="en-US" dirty="0"/>
           </a:p>
@@ -1327,7 +1336,7 @@
     <p:bg>
       <p:bgPr>
         <a:blipFill dpi="0" rotWithShape="1">
-          <a:blip r:embed="rId1">
+          <a:blip r:embed="rId2">
             <a:lum/>
           </a:blip>
           <a:srcRect/>
@@ -1540,6 +1549,30 @@
           </a:p>
         </p:txBody>
       </p:sp>
+      <p:pic>
+        <p:nvPicPr>
+          <p:cNvPr id="6" name="Image 0" descr="Camera circle: the presenter's video goes here">    </p:cNvPr>
+          <p:cNvPicPr>
+            <a:picLocks noChangeAspect="1"/>
+          </p:cNvPicPr>
+          <p:nvPr/>
+        </p:nvPicPr>
+        <p:blipFill>
+          <a:blip r:embed="rId1"/>
+          <a:stretch>
+            <a:fillRect/>
+          </a:stretch>
+        </p:blipFill>
+        <p:spPr>
+          <a:xfrm>
+            <a:off x="10058400" y="4754880"/>
+            <a:ext cx="1828800" cy="1828800"/>
+          </a:xfrm>
+          <a:prstGeom prst="rect">
+            <a:avLst/>
+          </a:prstGeom>
+        </p:spPr>
+      </p:pic>
     </p:spTree>
   </p:cSld>
   <p:clrMapOvr>
@@ -1553,423 +1586,8 @@
   <p:cSld name="Title only">
     <p:bg>
       <p:bgPr>
-        <a:solidFill>
-          <a:schemeClr val="bg1"/>
-        </a:solidFill>
-      </p:bgPr>
-    </p:bg>
-    <p:spTree>
-      <p:nvGrpSpPr>
-        <p:cNvPr id="1" name=""/>
-        <p:cNvGrpSpPr/>
-        <p:nvPr/>
-      </p:nvGrpSpPr>
-      <p:grpSpPr>
-        <a:xfrm>
-          <a:off x="0" y="0"/>
-          <a:ext cx="0" cy="0"/>
-          <a:chOff x="0" y="0"/>
-          <a:chExt cx="0" cy="0"/>
-        </a:xfrm>
-      </p:grpSpPr>
-      <p:sp>
-        <p:nvSpPr>
-          <p:cNvPr id="2" name="Text 0"/>
-          <p:cNvSpPr/>
-          <p:nvPr>
-            <p:ph idx="100" type="title" hasCustomPrompt="1"/>
-          </p:nvPr>
-        </p:nvSpPr>
-        <p:spPr>
-          <a:xfrm>
-            <a:off x="548640" y="411480"/>
-            <a:ext cx="11091672" cy="822960"/>
-          </a:xfrm>
-          <a:prstGeom prst="rect">
-            <a:avLst/>
-          </a:prstGeom>
-          <a:noFill/>
-          <a:ln/>
-        </p:spPr>
-        <p:txBody>
-          <a:bodyPr wrap="square" rtlCol="0"/>
-          <a:lstStyle>
-            <a:lvl1pPr algn="l" indent="0" marL="0">
-              <a:buNone/>
-              <a:defRPr lang="en-US" sz="3600" b="1" dirty="0">
-                <a:solidFill>
-                  <a:schemeClr val="tx1"/>
-                </a:solidFill>
-              </a:defRPr>
-            </a:lvl1pPr>
-          </a:lstStyle>
-          <a:p>
-            <a:pPr algn="l" indent="0" marL="0">
-              <a:buNone/>
-            </a:pPr>
-            <a:r>
-              <a:rPr lang="en-US" sz="3600" b="1" dirty="0">
-                <a:solidFill>
-                  <a:schemeClr val="tx1"/>
-                </a:solidFill>
-              </a:rPr>
-              <a:t>Slide title</a:t>
-            </a:r>
-            <a:endParaRPr lang="en-US" sz="3600" dirty="0"/>
-          </a:p>
-        </p:txBody>
-      </p:sp>
-      <p:pic>
-        <p:nvPicPr>
-          <p:cNvPr id="3" name="Image 0" descr="mark.png">    </p:cNvPr>
-          <p:cNvPicPr>
-            <a:picLocks noChangeAspect="1"/>
-          </p:cNvPicPr>
-          <p:nvPr/>
-        </p:nvPicPr>
-        <p:blipFill>
-          <a:blip r:embed="rId1"/>
-          <a:stretch>
-            <a:fillRect/>
-          </a:stretch>
-        </p:blipFill>
-        <p:spPr>
-          <a:xfrm>
-            <a:off x="548640" y="6336792"/>
-            <a:ext cx="292608" cy="292608"/>
-          </a:xfrm>
-          <a:prstGeom prst="rect">
-            <a:avLst/>
-          </a:prstGeom>
-        </p:spPr>
-      </p:pic>
-      <p:sp>
-        <p:nvSpPr>
-          <p:cNvPr id="4" name="Text 0"/>
-          <p:cNvSpPr/>
-          <p:nvPr/>
-        </p:nvSpPr>
-        <p:spPr>
-          <a:xfrm>
-            <a:off x="914400" y="6318504"/>
-            <a:ext cx="5486400" cy="329184"/>
-          </a:xfrm>
-          <a:prstGeom prst="rect">
-            <a:avLst/>
-          </a:prstGeom>
-          <a:noFill/>
-          <a:ln/>
-        </p:spPr>
-        <p:txBody>
-          <a:bodyPr wrap="square" lIns="0" tIns="0" rIns="0" bIns="0" rtlCol="0" anchor="ctr"/>
-          <a:lstStyle/>
-          <a:p>
-            <a:pPr indent="0" marL="0">
-              <a:buNone/>
-            </a:pPr>
-            <a:r>
-              <a:rPr lang="en-US" sz="1000" dirty="0">
-                <a:solidFill>
-                  <a:schemeClr val="accent6"/>
-                </a:solidFill>
-              </a:rPr>
-              <a:t>Beneath the Mesa  ·  ENG 220 Team 23</a:t>
-            </a:r>
-            <a:endParaRPr lang="en-US" sz="1000" dirty="0"/>
-          </a:p>
-        </p:txBody>
-      </p:sp>
-      <p:sp>
-        <p:nvSpPr>
-          <p:cNvPr id="25" name="Slide Number Placeholder 0"/>
-          <p:cNvSpPr>
-            <a:spLocks noGrp="1"/>
-          </p:cNvSpPr>
-          <p:nvPr>
-            <p:ph type="sldNum" sz="quarter" idx="4294967295"/>
-          </p:nvPr>
-        </p:nvSpPr>
-        <p:spPr>
-          <a:xfrm>
-            <a:off x="11091672" y="6318504"/>
-            <a:ext cx="548640" cy="329184"/>
-          </a:xfrm>
-          <a:prstGeom prst="rect">
-            <a:avLst/>
-          </a:prstGeom>
-          <a:extLst>
-            <a:ext uri="{C572A759-6A51-4108-AA02-DFA0A04FC94B}">
-              <ma14:wrappingTextBoxFlag xmlns:ma14="http://schemas.microsoft.com/office/mac/drawingml/2011/main" val="0"/>
-            </a:ext>
-          </a:extLst>
-        </p:spPr>
-        <p:txBody>
-          <a:bodyPr anchor="ctr"/>
-          <a:lstStyle>
-            <a:lvl1pPr>
-              <a:defRPr sz="1000">
-                <a:solidFill>
-                  <a:schemeClr val="accent6"/>
-                </a:solidFill>
-              </a:defRPr>
-            </a:lvl1pPr>
-          </a:lstStyle>
-          <a:p>
-            <a:pPr algn="r"/>
-            <a:fld id="{F7021451-1387-4CA6-816F-3879F97B5CBC}" type="slidenum">
-              <a:rPr b="0" lang="en-US"/>
-              <a:t>1003</a:t>
-            </a:fld>
-            <a:endParaRPr lang="en-US"/>
-          </a:p>
-        </p:txBody>
-      </p:sp>
-    </p:spTree>
-  </p:cSld>
-  <p:clrMapOvr>
-    <a:masterClrMapping/>
-  </p:clrMapOvr>
-</p:sldLayout>
-</file>
-
-<file path=ppt/slideLayouts/slideLayout4.xml><?xml version="1.0" encoding="utf-8"?>
-<p:sldLayout xmlns:a="http://schemas.openxmlformats.org/drawingml/2006/main" xmlns:r="http://schemas.openxmlformats.org/officeDocument/2006/relationships" xmlns:p="http://schemas.openxmlformats.org/presentationml/2006/main" preserve="1">
-  <p:cSld name="Title and content">
-    <p:bg>
-      <p:bgPr>
-        <a:solidFill>
-          <a:schemeClr val="bg1"/>
-        </a:solidFill>
-      </p:bgPr>
-    </p:bg>
-    <p:spTree>
-      <p:nvGrpSpPr>
-        <p:cNvPr id="1" name=""/>
-        <p:cNvGrpSpPr/>
-        <p:nvPr/>
-      </p:nvGrpSpPr>
-      <p:grpSpPr>
-        <a:xfrm>
-          <a:off x="0" y="0"/>
-          <a:ext cx="0" cy="0"/>
-          <a:chOff x="0" y="0"/>
-          <a:chExt cx="0" cy="0"/>
-        </a:xfrm>
-      </p:grpSpPr>
-      <p:sp>
-        <p:nvSpPr>
-          <p:cNvPr id="2" name="Text 0"/>
-          <p:cNvSpPr/>
-          <p:nvPr>
-            <p:ph idx="100" type="title" hasCustomPrompt="1"/>
-          </p:nvPr>
-        </p:nvSpPr>
-        <p:spPr>
-          <a:xfrm>
-            <a:off x="548640" y="411480"/>
-            <a:ext cx="11091672" cy="822960"/>
-          </a:xfrm>
-          <a:prstGeom prst="rect">
-            <a:avLst/>
-          </a:prstGeom>
-          <a:noFill/>
-          <a:ln/>
-        </p:spPr>
-        <p:txBody>
-          <a:bodyPr wrap="square" rtlCol="0"/>
-          <a:lstStyle>
-            <a:lvl1pPr algn="l" indent="0" marL="0">
-              <a:buNone/>
-              <a:defRPr lang="en-US" sz="3600" b="1" dirty="0">
-                <a:solidFill>
-                  <a:schemeClr val="tx1"/>
-                </a:solidFill>
-              </a:defRPr>
-            </a:lvl1pPr>
-          </a:lstStyle>
-          <a:p>
-            <a:pPr algn="l" indent="0" marL="0">
-              <a:buNone/>
-            </a:pPr>
-            <a:r>
-              <a:rPr lang="en-US" sz="3600" b="1" dirty="0">
-                <a:solidFill>
-                  <a:schemeClr val="tx1"/>
-                </a:solidFill>
-              </a:rPr>
-              <a:t>Slide title</a:t>
-            </a:r>
-            <a:endParaRPr lang="en-US" sz="3600" dirty="0"/>
-          </a:p>
-        </p:txBody>
-      </p:sp>
-      <p:sp>
-        <p:nvSpPr>
-          <p:cNvPr id="3" name="Text 0"/>
-          <p:cNvSpPr/>
-          <p:nvPr>
-            <p:ph idx="101" type="body" hasCustomPrompt="1"/>
-          </p:nvPr>
-        </p:nvSpPr>
-        <p:spPr>
-          <a:xfrm>
-            <a:off x="548640" y="1508760"/>
-            <a:ext cx="5394960" cy="4434840"/>
-          </a:xfrm>
-          <a:prstGeom prst="rect">
-            <a:avLst/>
-          </a:prstGeom>
-          <a:noFill/>
-          <a:ln/>
-        </p:spPr>
-        <p:txBody>
-          <a:bodyPr wrap="square" rtlCol="0"/>
-          <a:lstStyle>
-            <a:lvl1pPr indent="0" marL="0">
-              <a:buNone/>
-              <a:defRPr lang="en-US" sz="1800" dirty="0">
-                <a:solidFill>
-                  <a:schemeClr val="tx1"/>
-                </a:solidFill>
-              </a:defRPr>
-            </a:lvl1pPr>
-          </a:lstStyle>
-          <a:p>
-            <a:pPr indent="0" marL="0">
-              <a:buNone/>
-            </a:pPr>
-            <a:r>
-              <a:rPr lang="en-US" sz="1800" dirty="0">
-                <a:solidFill>
-                  <a:schemeClr val="tx1"/>
-                </a:solidFill>
-              </a:rPr>
-              <a:t>Add bullet points</a:t>
-            </a:r>
-            <a:endParaRPr lang="en-US" sz="1800" dirty="0"/>
-          </a:p>
-        </p:txBody>
-      </p:sp>
-      <p:pic>
-        <p:nvPicPr>
-          <p:cNvPr id="4" name="Image 0" descr="mark.png">    </p:cNvPr>
-          <p:cNvPicPr>
-            <a:picLocks noChangeAspect="1"/>
-          </p:cNvPicPr>
-          <p:nvPr/>
-        </p:nvPicPr>
-        <p:blipFill>
-          <a:blip r:embed="rId1"/>
-          <a:stretch>
-            <a:fillRect/>
-          </a:stretch>
-        </p:blipFill>
-        <p:spPr>
-          <a:xfrm>
-            <a:off x="548640" y="6336792"/>
-            <a:ext cx="292608" cy="292608"/>
-          </a:xfrm>
-          <a:prstGeom prst="rect">
-            <a:avLst/>
-          </a:prstGeom>
-        </p:spPr>
-      </p:pic>
-      <p:sp>
-        <p:nvSpPr>
-          <p:cNvPr id="5" name="Text 0"/>
-          <p:cNvSpPr/>
-          <p:nvPr/>
-        </p:nvSpPr>
-        <p:spPr>
-          <a:xfrm>
-            <a:off x="914400" y="6318504"/>
-            <a:ext cx="5486400" cy="329184"/>
-          </a:xfrm>
-          <a:prstGeom prst="rect">
-            <a:avLst/>
-          </a:prstGeom>
-          <a:noFill/>
-          <a:ln/>
-        </p:spPr>
-        <p:txBody>
-          <a:bodyPr wrap="square" lIns="0" tIns="0" rIns="0" bIns="0" rtlCol="0" anchor="ctr"/>
-          <a:lstStyle/>
-          <a:p>
-            <a:pPr indent="0" marL="0">
-              <a:buNone/>
-            </a:pPr>
-            <a:r>
-              <a:rPr lang="en-US" sz="1000" dirty="0">
-                <a:solidFill>
-                  <a:schemeClr val="accent6"/>
-                </a:solidFill>
-              </a:rPr>
-              <a:t>Beneath the Mesa  ·  ENG 220 Team 23</a:t>
-            </a:r>
-            <a:endParaRPr lang="en-US" sz="1000" dirty="0"/>
-          </a:p>
-        </p:txBody>
-      </p:sp>
-      <p:sp>
-        <p:nvSpPr>
-          <p:cNvPr id="25" name="Slide Number Placeholder 0"/>
-          <p:cNvSpPr>
-            <a:spLocks noGrp="1"/>
-          </p:cNvSpPr>
-          <p:nvPr>
-            <p:ph type="sldNum" sz="quarter" idx="4294967295"/>
-          </p:nvPr>
-        </p:nvSpPr>
-        <p:spPr>
-          <a:xfrm>
-            <a:off x="11091672" y="6318504"/>
-            <a:ext cx="548640" cy="329184"/>
-          </a:xfrm>
-          <a:prstGeom prst="rect">
-            <a:avLst/>
-          </a:prstGeom>
-          <a:extLst>
-            <a:ext uri="{C572A759-6A51-4108-AA02-DFA0A04FC94B}">
-              <ma14:wrappingTextBoxFlag xmlns:ma14="http://schemas.microsoft.com/office/mac/drawingml/2011/main" val="0"/>
-            </a:ext>
-          </a:extLst>
-        </p:spPr>
-        <p:txBody>
-          <a:bodyPr anchor="ctr"/>
-          <a:lstStyle>
-            <a:lvl1pPr>
-              <a:defRPr sz="1000">
-                <a:solidFill>
-                  <a:schemeClr val="accent6"/>
-                </a:solidFill>
-              </a:defRPr>
-            </a:lvl1pPr>
-          </a:lstStyle>
-          <a:p>
-            <a:pPr algn="r"/>
-            <a:fld id="{F7021451-1387-4CA6-816F-3879F97B5CBC}" type="slidenum">
-              <a:rPr b="0" lang="en-US"/>
-              <a:t>1004</a:t>
-            </a:fld>
-            <a:endParaRPr lang="en-US"/>
-          </a:p>
-        </p:txBody>
-      </p:sp>
-    </p:spTree>
-  </p:cSld>
-  <p:clrMapOvr>
-    <a:masterClrMapping/>
-  </p:clrMapOvr>
-</p:sldLayout>
-</file>
-
-<file path=ppt/slideLayouts/slideLayout5.xml><?xml version="1.0" encoding="utf-8"?>
-<p:sldLayout xmlns:a="http://schemas.openxmlformats.org/drawingml/2006/main" xmlns:r="http://schemas.openxmlformats.org/officeDocument/2006/relationships" xmlns:p="http://schemas.openxmlformats.org/presentationml/2006/main" preserve="1">
-  <p:cSld name="Closing (dark)">
-    <p:bg>
-      <p:bgPr>
         <a:blipFill dpi="0" rotWithShape="1">
-          <a:blip r:embed="rId1">
+          <a:blip r:embed="rId2">
             <a:lum/>
           </a:blip>
           <a:srcRect/>
@@ -2004,8 +1622,8 @@
         </p:nvSpPr>
         <p:spPr>
           <a:xfrm>
-            <a:off x="731520" y="457200"/>
-            <a:ext cx="10698480" cy="777240"/>
+            <a:off x="548640" y="182880"/>
+            <a:ext cx="7315200" cy="822960"/>
           </a:xfrm>
           <a:prstGeom prst="rect">
             <a:avLst/>
@@ -2035,12 +1653,465 @@
                   <a:schemeClr val="bg1"/>
                 </a:solidFill>
               </a:rPr>
+              <a:t>Slide title</a:t>
+            </a:r>
+            <a:endParaRPr lang="en-US" sz="3600" dirty="0"/>
+          </a:p>
+        </p:txBody>
+      </p:sp>
+      <p:sp>
+        <p:nvSpPr>
+          <p:cNvPr id="3" name="Text 0"/>
+          <p:cNvSpPr/>
+          <p:nvPr/>
+        </p:nvSpPr>
+        <p:spPr>
+          <a:xfrm>
+            <a:off x="960120" y="6400800"/>
+            <a:ext cx="4572000" cy="292608"/>
+          </a:xfrm>
+          <a:prstGeom prst="rect">
+            <a:avLst/>
+          </a:prstGeom>
+          <a:noFill/>
+          <a:ln/>
+        </p:spPr>
+        <p:txBody>
+          <a:bodyPr wrap="square" lIns="0" tIns="0" rIns="0" bIns="0" rtlCol="0" anchor="ctr"/>
+          <a:lstStyle/>
+          <a:p>
+            <a:pPr indent="0" marL="0">
+              <a:buNone/>
+            </a:pPr>
+            <a:r>
+              <a:rPr lang="en-US" sz="1000" dirty="0">
+                <a:solidFill>
+                  <a:schemeClr val="bg2"/>
+                </a:solidFill>
+              </a:rPr>
+              <a:t>Beneath the Mesa  ·  ENG 220 Team 23</a:t>
+            </a:r>
+            <a:endParaRPr lang="en-US" sz="1000" dirty="0"/>
+          </a:p>
+        </p:txBody>
+      </p:sp>
+      <p:pic>
+        <p:nvPicPr>
+          <p:cNvPr id="4" name="Image 0" descr="Camera circle: the presenter's video goes here">    </p:cNvPr>
+          <p:cNvPicPr>
+            <a:picLocks noChangeAspect="1"/>
+          </p:cNvPicPr>
+          <p:nvPr/>
+        </p:nvPicPr>
+        <p:blipFill>
+          <a:blip r:embed="rId1"/>
+          <a:stretch>
+            <a:fillRect/>
+          </a:stretch>
+        </p:blipFill>
+        <p:spPr>
+          <a:xfrm>
+            <a:off x="10058400" y="4754880"/>
+            <a:ext cx="1828800" cy="1828800"/>
+          </a:xfrm>
+          <a:prstGeom prst="rect">
+            <a:avLst/>
+          </a:prstGeom>
+        </p:spPr>
+      </p:pic>
+      <p:sp>
+        <p:nvSpPr>
+          <p:cNvPr id="25" name="Slide Number Placeholder 0"/>
+          <p:cNvSpPr>
+            <a:spLocks noGrp="1"/>
+          </p:cNvSpPr>
+          <p:nvPr>
+            <p:ph type="sldNum" sz="quarter" idx="4294967295"/>
+          </p:nvPr>
+        </p:nvSpPr>
+        <p:spPr>
+          <a:xfrm>
+            <a:off x="548640" y="6400800"/>
+            <a:ext cx="365760" cy="292608"/>
+          </a:xfrm>
+          <a:prstGeom prst="rect">
+            <a:avLst/>
+          </a:prstGeom>
+          <a:extLst>
+            <a:ext uri="{C572A759-6A51-4108-AA02-DFA0A04FC94B}">
+              <ma14:wrappingTextBoxFlag xmlns:ma14="http://schemas.microsoft.com/office/mac/drawingml/2011/main" val="0"/>
+            </a:ext>
+          </a:extLst>
+        </p:spPr>
+        <p:txBody>
+          <a:bodyPr lIns="0" tIns="0" rIns="0" bIns="0" anchor="ctr"/>
+          <a:lstStyle>
+            <a:lvl1pPr>
+              <a:defRPr sz="1000">
+                <a:solidFill>
+                  <a:schemeClr val="bg1"/>
+                </a:solidFill>
+              </a:defRPr>
+            </a:lvl1pPr>
+          </a:lstStyle>
+          <a:p>
+            <a:pPr algn="l"/>
+            <a:fld id="{F7021451-1387-4CA6-816F-3879F97B5CBC}" type="slidenum">
+              <a:rPr b="1" lang="en-US"/>
+              <a:t>1003</a:t>
+            </a:fld>
+            <a:endParaRPr lang="en-US"/>
+          </a:p>
+        </p:txBody>
+      </p:sp>
+    </p:spTree>
+  </p:cSld>
+  <p:clrMapOvr>
+    <a:masterClrMapping/>
+  </p:clrMapOvr>
+</p:sldLayout>
+</file>
+
+<file path=ppt/slideLayouts/slideLayout4.xml><?xml version="1.0" encoding="utf-8"?>
+<p:sldLayout xmlns:a="http://schemas.openxmlformats.org/drawingml/2006/main" xmlns:r="http://schemas.openxmlformats.org/officeDocument/2006/relationships" xmlns:p="http://schemas.openxmlformats.org/presentationml/2006/main" preserve="1">
+  <p:cSld name="Title and content">
+    <p:bg>
+      <p:bgPr>
+        <a:blipFill dpi="0" rotWithShape="1">
+          <a:blip r:embed="rId2">
+            <a:lum/>
+          </a:blip>
+          <a:srcRect/>
+          <a:stretch>
+            <a:fillRect/>
+          </a:stretch>
+        </a:blipFill>
+        <a:effectLst/>
+      </p:bgPr>
+    </p:bg>
+    <p:spTree>
+      <p:nvGrpSpPr>
+        <p:cNvPr id="1" name=""/>
+        <p:cNvGrpSpPr/>
+        <p:nvPr/>
+      </p:nvGrpSpPr>
+      <p:grpSpPr>
+        <a:xfrm>
+          <a:off x="0" y="0"/>
+          <a:ext cx="0" cy="0"/>
+          <a:chOff x="0" y="0"/>
+          <a:chExt cx="0" cy="0"/>
+        </a:xfrm>
+      </p:grpSpPr>
+      <p:sp>
+        <p:nvSpPr>
+          <p:cNvPr id="2" name="Text 0"/>
+          <p:cNvSpPr/>
+          <p:nvPr>
+            <p:ph idx="100" type="title" hasCustomPrompt="1"/>
+          </p:nvPr>
+        </p:nvSpPr>
+        <p:spPr>
+          <a:xfrm>
+            <a:off x="548640" y="182880"/>
+            <a:ext cx="7315200" cy="822960"/>
+          </a:xfrm>
+          <a:prstGeom prst="rect">
+            <a:avLst/>
+          </a:prstGeom>
+          <a:noFill/>
+          <a:ln/>
+        </p:spPr>
+        <p:txBody>
+          <a:bodyPr wrap="square" rtlCol="0"/>
+          <a:lstStyle>
+            <a:lvl1pPr algn="l" indent="0" marL="0">
+              <a:buNone/>
+              <a:defRPr lang="en-US" sz="3600" b="1" dirty="0">
+                <a:solidFill>
+                  <a:schemeClr val="bg1"/>
+                </a:solidFill>
+              </a:defRPr>
+            </a:lvl1pPr>
+          </a:lstStyle>
+          <a:p>
+            <a:pPr algn="l" indent="0" marL="0">
+              <a:buNone/>
+            </a:pPr>
+            <a:r>
+              <a:rPr lang="en-US" sz="3600" b="1" dirty="0">
+                <a:solidFill>
+                  <a:schemeClr val="bg1"/>
+                </a:solidFill>
+              </a:rPr>
+              <a:t>Slide title</a:t>
+            </a:r>
+            <a:endParaRPr lang="en-US" sz="3600" dirty="0"/>
+          </a:p>
+        </p:txBody>
+      </p:sp>
+      <p:sp>
+        <p:nvSpPr>
+          <p:cNvPr id="3" name="Text 0"/>
+          <p:cNvSpPr/>
+          <p:nvPr>
+            <p:ph idx="101" type="body" hasCustomPrompt="1"/>
+          </p:nvPr>
+        </p:nvSpPr>
+        <p:spPr>
+          <a:xfrm>
+            <a:off x="548640" y="1508760"/>
+            <a:ext cx="5120640" cy="4343400"/>
+          </a:xfrm>
+          <a:prstGeom prst="rect">
+            <a:avLst/>
+          </a:prstGeom>
+          <a:noFill/>
+          <a:ln/>
+        </p:spPr>
+        <p:txBody>
+          <a:bodyPr wrap="square" rtlCol="0"/>
+          <a:lstStyle>
+            <a:lvl1pPr indent="0" marL="0">
+              <a:buNone/>
+              <a:defRPr lang="en-US" sz="1800" dirty="0">
+                <a:solidFill>
+                  <a:schemeClr val="tx1"/>
+                </a:solidFill>
+              </a:defRPr>
+            </a:lvl1pPr>
+          </a:lstStyle>
+          <a:p>
+            <a:pPr indent="0" marL="0">
+              <a:buNone/>
+            </a:pPr>
+            <a:r>
+              <a:rPr lang="en-US" sz="1800" dirty="0">
+                <a:solidFill>
+                  <a:schemeClr val="tx1"/>
+                </a:solidFill>
+              </a:rPr>
+              <a:t>Add bullet points</a:t>
+            </a:r>
+            <a:endParaRPr lang="en-US" sz="1800" dirty="0"/>
+          </a:p>
+        </p:txBody>
+      </p:sp>
+      <p:sp>
+        <p:nvSpPr>
+          <p:cNvPr id="4" name="Text 0"/>
+          <p:cNvSpPr/>
+          <p:nvPr/>
+        </p:nvSpPr>
+        <p:spPr>
+          <a:xfrm>
+            <a:off x="960120" y="6400800"/>
+            <a:ext cx="4572000" cy="292608"/>
+          </a:xfrm>
+          <a:prstGeom prst="rect">
+            <a:avLst/>
+          </a:prstGeom>
+          <a:noFill/>
+          <a:ln/>
+        </p:spPr>
+        <p:txBody>
+          <a:bodyPr wrap="square" lIns="0" tIns="0" rIns="0" bIns="0" rtlCol="0" anchor="ctr"/>
+          <a:lstStyle/>
+          <a:p>
+            <a:pPr indent="0" marL="0">
+              <a:buNone/>
+            </a:pPr>
+            <a:r>
+              <a:rPr lang="en-US" sz="1000" dirty="0">
+                <a:solidFill>
+                  <a:schemeClr val="bg2"/>
+                </a:solidFill>
+              </a:rPr>
+              <a:t>Beneath the Mesa  ·  ENG 220 Team 23</a:t>
+            </a:r>
+            <a:endParaRPr lang="en-US" sz="1000" dirty="0"/>
+          </a:p>
+        </p:txBody>
+      </p:sp>
+      <p:pic>
+        <p:nvPicPr>
+          <p:cNvPr id="5" name="Image 0" descr="Camera circle: the presenter's video goes here">    </p:cNvPr>
+          <p:cNvPicPr>
+            <a:picLocks noChangeAspect="1"/>
+          </p:cNvPicPr>
+          <p:nvPr/>
+        </p:nvPicPr>
+        <p:blipFill>
+          <a:blip r:embed="rId1"/>
+          <a:stretch>
+            <a:fillRect/>
+          </a:stretch>
+        </p:blipFill>
+        <p:spPr>
+          <a:xfrm>
+            <a:off x="10058400" y="4754880"/>
+            <a:ext cx="1828800" cy="1828800"/>
+          </a:xfrm>
+          <a:prstGeom prst="rect">
+            <a:avLst/>
+          </a:prstGeom>
+        </p:spPr>
+      </p:pic>
+      <p:sp>
+        <p:nvSpPr>
+          <p:cNvPr id="25" name="Slide Number Placeholder 0"/>
+          <p:cNvSpPr>
+            <a:spLocks noGrp="1"/>
+          </p:cNvSpPr>
+          <p:nvPr>
+            <p:ph type="sldNum" sz="quarter" idx="4294967295"/>
+          </p:nvPr>
+        </p:nvSpPr>
+        <p:spPr>
+          <a:xfrm>
+            <a:off x="548640" y="6400800"/>
+            <a:ext cx="365760" cy="292608"/>
+          </a:xfrm>
+          <a:prstGeom prst="rect">
+            <a:avLst/>
+          </a:prstGeom>
+          <a:extLst>
+            <a:ext uri="{C572A759-6A51-4108-AA02-DFA0A04FC94B}">
+              <ma14:wrappingTextBoxFlag xmlns:ma14="http://schemas.microsoft.com/office/mac/drawingml/2011/main" val="0"/>
+            </a:ext>
+          </a:extLst>
+        </p:spPr>
+        <p:txBody>
+          <a:bodyPr lIns="0" tIns="0" rIns="0" bIns="0" anchor="ctr"/>
+          <a:lstStyle>
+            <a:lvl1pPr>
+              <a:defRPr sz="1000">
+                <a:solidFill>
+                  <a:schemeClr val="bg1"/>
+                </a:solidFill>
+              </a:defRPr>
+            </a:lvl1pPr>
+          </a:lstStyle>
+          <a:p>
+            <a:pPr algn="l"/>
+            <a:fld id="{F7021451-1387-4CA6-816F-3879F97B5CBC}" type="slidenum">
+              <a:rPr b="1" lang="en-US"/>
+              <a:t>1004</a:t>
+            </a:fld>
+            <a:endParaRPr lang="en-US"/>
+          </a:p>
+        </p:txBody>
+      </p:sp>
+    </p:spTree>
+  </p:cSld>
+  <p:clrMapOvr>
+    <a:masterClrMapping/>
+  </p:clrMapOvr>
+</p:sldLayout>
+</file>
+
+<file path=ppt/slideLayouts/slideLayout5.xml><?xml version="1.0" encoding="utf-8"?>
+<p:sldLayout xmlns:a="http://schemas.openxmlformats.org/drawingml/2006/main" xmlns:r="http://schemas.openxmlformats.org/officeDocument/2006/relationships" xmlns:p="http://schemas.openxmlformats.org/presentationml/2006/main" preserve="1">
+  <p:cSld name="Closing (dark)">
+    <p:bg>
+      <p:bgPr>
+        <a:blipFill dpi="0" rotWithShape="1">
+          <a:blip r:embed="rId2">
+            <a:lum/>
+          </a:blip>
+          <a:srcRect/>
+          <a:stretch>
+            <a:fillRect/>
+          </a:stretch>
+        </a:blipFill>
+        <a:effectLst/>
+      </p:bgPr>
+    </p:bg>
+    <p:spTree>
+      <p:nvGrpSpPr>
+        <p:cNvPr id="1" name=""/>
+        <p:cNvGrpSpPr/>
+        <p:nvPr/>
+      </p:nvGrpSpPr>
+      <p:grpSpPr>
+        <a:xfrm>
+          <a:off x="0" y="0"/>
+          <a:ext cx="0" cy="0"/>
+          <a:chOff x="0" y="0"/>
+          <a:chExt cx="0" cy="0"/>
+        </a:xfrm>
+      </p:grpSpPr>
+      <p:sp>
+        <p:nvSpPr>
+          <p:cNvPr id="2" name="Text 0"/>
+          <p:cNvSpPr/>
+          <p:nvPr>
+            <p:ph idx="100" type="title" hasCustomPrompt="1"/>
+          </p:nvPr>
+        </p:nvSpPr>
+        <p:spPr>
+          <a:xfrm>
+            <a:off x="731520" y="457200"/>
+            <a:ext cx="10698480" cy="777240"/>
+          </a:xfrm>
+          <a:prstGeom prst="rect">
+            <a:avLst/>
+          </a:prstGeom>
+          <a:noFill/>
+          <a:ln/>
+        </p:spPr>
+        <p:txBody>
+          <a:bodyPr wrap="square" rtlCol="0"/>
+          <a:lstStyle>
+            <a:lvl1pPr algn="l" indent="0" marL="0">
+              <a:buNone/>
+              <a:defRPr lang="en-US" sz="3600" b="1" dirty="0">
+                <a:solidFill>
+                  <a:schemeClr val="bg1"/>
+                </a:solidFill>
+              </a:defRPr>
+            </a:lvl1pPr>
+          </a:lstStyle>
+          <a:p>
+            <a:pPr algn="l" indent="0" marL="0">
+              <a:buNone/>
+            </a:pPr>
+            <a:r>
+              <a:rPr lang="en-US" sz="3600" b="1" dirty="0">
+                <a:solidFill>
+                  <a:schemeClr val="bg1"/>
+                </a:solidFill>
+              </a:rPr>
               <a:t>Closing title</a:t>
             </a:r>
             <a:endParaRPr lang="en-US" sz="3600" dirty="0"/>
           </a:p>
         </p:txBody>
       </p:sp>
+      <p:pic>
+        <p:nvPicPr>
+          <p:cNvPr id="3" name="Image 0" descr="Camera circle: the presenter's video goes here">    </p:cNvPr>
+          <p:cNvPicPr>
+            <a:picLocks noChangeAspect="1"/>
+          </p:cNvPicPr>
+          <p:nvPr/>
+        </p:nvPicPr>
+        <p:blipFill>
+          <a:blip r:embed="rId1"/>
+          <a:stretch>
+            <a:fillRect/>
+          </a:stretch>
+        </p:blipFill>
+        <p:spPr>
+          <a:xfrm>
+            <a:off x="10058400" y="4754880"/>
+            <a:ext cx="1828800" cy="1828800"/>
+          </a:xfrm>
+          <a:prstGeom prst="rect">
+            <a:avLst/>
+          </a:prstGeom>
+        </p:spPr>
+      </p:pic>
     </p:spTree>
   </p:cSld>
   <p:clrMapOvr>
@@ -2078,8 +2149,8 @@
         </p:nvSpPr>
         <p:spPr>
           <a:xfrm>
-            <a:off x="11091672" y="6318504"/>
-            <a:ext cx="548640" cy="329184"/>
+            <a:off x="548640" y="6400800"/>
+            <a:ext cx="365760" cy="292608"/>
           </a:xfrm>
           <a:prstGeom prst="rect">
             <a:avLst/>
@@ -2091,20 +2162,20 @@
           </a:extLst>
         </p:spPr>
         <p:txBody>
-          <a:bodyPr anchor="ctr"/>
+          <a:bodyPr lIns="0" tIns="0" rIns="0" bIns="0" anchor="ctr"/>
           <a:lstStyle>
             <a:lvl1pPr>
               <a:defRPr sz="1000">
                 <a:solidFill>
-                  <a:schemeClr val="accent6"/>
+                  <a:schemeClr val="bg1"/>
                 </a:solidFill>
               </a:defRPr>
             </a:lvl1pPr>
           </a:lstStyle>
           <a:p>
-            <a:pPr algn="r"/>
+            <a:pPr algn="l"/>
             <a:fld id="{F7021451-1387-4CA6-816F-3879F97B5CBC}" type="slidenum">
-              <a:rPr b="0" lang="en-US"/>
+              <a:rPr b="1" lang="en-US"/>
               <a:t>null</a:t>
             </a:fld>
             <a:endParaRPr lang="en-US"/>
@@ -2593,8 +2664,8 @@
         </p:nvSpPr>
         <p:spPr>
           <a:xfrm>
-            <a:off x="548640" y="411480"/>
-            <a:ext cx="11091672" cy="822960"/>
+            <a:off x="548640" y="182880"/>
+            <a:ext cx="7315200" cy="822960"/>
           </a:xfrm>
           <a:prstGeom prst="rect">
             <a:avLst/>
@@ -2612,7 +2683,7 @@
             <a:r>
               <a:rPr lang="en-US" sz="3600" b="1" dirty="0">
                 <a:solidFill>
-                  <a:schemeClr val="tx1"/>
+                  <a:schemeClr val="bg1"/>
                 </a:solidFill>
               </a:rPr>
               <a:t>Background</a:t>
@@ -2632,7 +2703,7 @@
         <p:spPr>
           <a:xfrm>
             <a:off x="548640" y="1508760"/>
-            <a:ext cx="5394960" cy="4434840"/>
+            <a:ext cx="5120640" cy="4343400"/>
           </a:xfrm>
           <a:prstGeom prst="rect">
             <a:avLst/>
@@ -2725,12 +2796,12 @@
         </p:nvSpPr>
         <p:spPr>
           <a:xfrm>
-            <a:off x="6355080" y="1508760"/>
-            <a:ext cx="5285232" cy="4434840"/>
+            <a:off x="6035040" y="1508760"/>
+            <a:ext cx="5605272" cy="2697480"/>
           </a:xfrm>
           <a:prstGeom prst="roundRect">
             <a:avLst>
-              <a:gd name="adj" fmla="val 2474"/>
+              <a:gd name="adj" fmla="val 4068"/>
             </a:avLst>
           </a:prstGeom>
           <a:solidFill>
@@ -2752,8 +2823,8 @@
         </p:nvSpPr>
         <p:spPr>
           <a:xfrm>
-            <a:off x="8586216" y="2857500"/>
-            <a:ext cx="822960" cy="822960"/>
+            <a:off x="8471916" y="2034540"/>
+            <a:ext cx="731520" cy="731520"/>
           </a:xfrm>
           <a:prstGeom prst="ellipse">
             <a:avLst/>
@@ -2780,8 +2851,8 @@
         </p:blipFill>
         <p:spPr>
           <a:xfrm>
-            <a:off x="8791956" y="3063240"/>
-            <a:ext cx="411480" cy="411480"/>
+            <a:off x="8654796" y="2217420"/>
+            <a:ext cx="365760" cy="365760"/>
           </a:xfrm>
           <a:prstGeom prst="rect">
             <a:avLst/>
@@ -2796,8 +2867,8 @@
         </p:nvSpPr>
         <p:spPr>
           <a:xfrm>
-            <a:off x="6720840" y="3817620"/>
-            <a:ext cx="4553712" cy="868680"/>
+            <a:off x="6400800" y="2903220"/>
+            <a:ext cx="4873752" cy="777240"/>
           </a:xfrm>
           <a:prstGeom prst="rect">
             <a:avLst/>
@@ -2841,6 +2912,42 @@
               <a:t>Sandoval County with Cuba marked</a:t>
             </a:r>
             <a:endParaRPr lang="en-US" sz="1800" dirty="0"/>
+          </a:p>
+        </p:txBody>
+      </p:sp>
+      <p:sp>
+        <p:nvSpPr>
+          <p:cNvPr id="8" name="Caption"/>
+          <p:cNvSpPr txBox="1"/>
+          <p:nvPr/>
+        </p:nvSpPr>
+        <p:spPr>
+          <a:xfrm>
+            <a:off x="6035040" y="4343400"/>
+            <a:ext cx="3566160" cy="320040"/>
+          </a:xfrm>
+          <a:prstGeom prst="rect">
+            <a:avLst/>
+          </a:prstGeom>
+          <a:noFill/>
+          <a:ln/>
+        </p:spPr>
+        <p:txBody>
+          <a:bodyPr wrap="square" lIns="0" tIns="0" rIns="0" bIns="0" rtlCol="0" anchor="t"/>
+          <a:lstStyle/>
+          <a:p>
+            <a:pPr indent="0" marL="0">
+              <a:buNone/>
+            </a:pPr>
+            <a:r>
+              <a:rPr lang="en-US" sz="1200" i="1" dirty="0">
+                <a:solidFill>
+                  <a:schemeClr val="accent6"/>
+                </a:solidFill>
+              </a:rPr>
+              <a:t>Figure caption and source</a:t>
+            </a:r>
+            <a:endParaRPr lang="en-US" sz="1200" dirty="0"/>
           </a:p>
         </p:txBody>
       </p:sp>
@@ -2856,8 +2963,8 @@
         </p:nvSpPr>
         <p:spPr>
           <a:xfrm>
-            <a:off x="11091672" y="6318504"/>
-            <a:ext cx="548640" cy="329184"/>
+            <a:off x="548640" y="6400800"/>
+            <a:ext cx="365760" cy="292608"/>
           </a:xfrm>
           <a:prstGeom prst="rect">
             <a:avLst/>
@@ -2869,20 +2976,20 @@
           </a:extLst>
         </p:spPr>
         <p:txBody>
-          <a:bodyPr anchor="ctr"/>
+          <a:bodyPr lIns="0" tIns="0" rIns="0" bIns="0" anchor="ctr"/>
           <a:lstStyle>
             <a:lvl1pPr>
               <a:defRPr sz="1000">
                 <a:solidFill>
-                  <a:schemeClr val="accent6"/>
+                  <a:schemeClr val="bg1"/>
                 </a:solidFill>
               </a:defRPr>
             </a:lvl1pPr>
           </a:lstStyle>
           <a:p>
-            <a:pPr algn="r"/>
+            <a:pPr algn="l"/>
             <a:fld id="{F7021451-1387-4CA6-816F-3879F97B5CBC}" type="slidenum">
-              <a:rPr b="0" lang="en-US"/>
+              <a:rPr b="1" lang="en-US"/>
               <a:t>2</a:t>
             </a:fld>
             <a:endParaRPr lang="en-US"/>
@@ -2924,8 +3031,8 @@
         </p:nvSpPr>
         <p:spPr>
           <a:xfrm>
-            <a:off x="548640" y="411480"/>
-            <a:ext cx="11091672" cy="822960"/>
+            <a:off x="548640" y="182880"/>
+            <a:ext cx="7315200" cy="822960"/>
           </a:xfrm>
           <a:prstGeom prst="rect">
             <a:avLst/>
@@ -2943,7 +3050,7 @@
             <a:r>
               <a:rPr lang="en-US" sz="3600" b="1" dirty="0">
                 <a:solidFill>
-                  <a:schemeClr val="tx1"/>
+                  <a:schemeClr val="bg1"/>
                 </a:solidFill>
               </a:rPr>
               <a:t>Research questions</a:t>
@@ -2954,18 +3061,159 @@
       </p:sp>
       <p:sp>
         <p:nvSpPr>
-          <p:cNvPr id="3" name="Question 1 card"/>
+          <p:cNvPr id="3" name="Main question card"/>
           <p:cNvSpPr/>
           <p:nvPr/>
         </p:nvSpPr>
         <p:spPr>
           <a:xfrm>
-            <a:off x="548640" y="1600200"/>
-            <a:ext cx="3529584" cy="4206240"/>
+            <a:off x="548640" y="1508760"/>
+            <a:ext cx="3429000" cy="4343400"/>
           </a:xfrm>
           <a:prstGeom prst="roundRect">
             <a:avLst>
-              <a:gd name="adj" fmla="val 3109"/>
+              <a:gd name="adj" fmla="val 3200"/>
+            </a:avLst>
+          </a:prstGeom>
+          <a:solidFill>
+            <a:schemeClr val="accent1"/>
+          </a:solidFill>
+          <a:ln/>
+        </p:spPr>
+      </p:sp>
+      <p:sp>
+        <p:nvSpPr>
+          <p:cNvPr id="4" name="Main question circle"/>
+          <p:cNvSpPr/>
+          <p:nvPr/>
+        </p:nvSpPr>
+        <p:spPr>
+          <a:xfrm>
+            <a:off x="868680" y="1828800"/>
+            <a:ext cx="731520" cy="731520"/>
+          </a:xfrm>
+          <a:prstGeom prst="ellipse">
+            <a:avLst/>
+          </a:prstGeom>
+          <a:solidFill>
+            <a:schemeClr val="bg1"/>
+          </a:solidFill>
+          <a:ln/>
+        </p:spPr>
+      </p:sp>
+      <p:pic>
+        <p:nvPicPr>
+          <p:cNvPr id="5" name="Main question icon" descr="preencoded.png">    </p:cNvPr>
+          <p:cNvPicPr>
+            <a:picLocks noChangeAspect="1"/>
+          </p:cNvPicPr>
+          <p:nvPr/>
+        </p:nvPicPr>
+        <p:blipFill>
+          <a:blip r:embed="rId1"/>
+          <a:stretch>
+            <a:fillRect/>
+          </a:stretch>
+        </p:blipFill>
+        <p:spPr>
+          <a:xfrm>
+            <a:off x="1051560" y="2011680"/>
+            <a:ext cx="365760" cy="365760"/>
+          </a:xfrm>
+          <a:prstGeom prst="rect">
+            <a:avLst/>
+          </a:prstGeom>
+        </p:spPr>
+      </p:pic>
+      <p:sp>
+        <p:nvSpPr>
+          <p:cNvPr id="6" name="Text 3"/>
+          <p:cNvSpPr txBox="1"/>
+          <p:nvPr/>
+        </p:nvSpPr>
+        <p:spPr>
+          <a:xfrm>
+            <a:off x="868680" y="2834640"/>
+            <a:ext cx="2788920" cy="320040"/>
+          </a:xfrm>
+          <a:prstGeom prst="rect">
+            <a:avLst/>
+          </a:prstGeom>
+          <a:noFill/>
+          <a:ln/>
+        </p:spPr>
+        <p:txBody>
+          <a:bodyPr wrap="square" lIns="0" tIns="0" rIns="0" bIns="0" rtlCol="0" anchor="t"/>
+          <a:lstStyle/>
+          <a:p>
+            <a:pPr indent="0" marL="0">
+              <a:buNone/>
+            </a:pPr>
+            <a:r>
+              <a:rPr lang="en-US" sz="1400" b="1" spc="200" kern="0" dirty="0">
+                <a:solidFill>
+                  <a:schemeClr val="bg2"/>
+                </a:solidFill>
+              </a:rPr>
+              <a:t>MAIN QUESTION</a:t>
+            </a:r>
+            <a:endParaRPr lang="en-US" sz="1400" dirty="0"/>
+          </a:p>
+        </p:txBody>
+      </p:sp>
+      <p:sp>
+        <p:nvSpPr>
+          <p:cNvPr id="7" name="Text 4"/>
+          <p:cNvSpPr txBox="1"/>
+          <p:nvPr/>
+        </p:nvSpPr>
+        <p:spPr>
+          <a:xfrm>
+            <a:off x="868680" y="3200400"/>
+            <a:ext cx="2788920" cy="2286000"/>
+          </a:xfrm>
+          <a:prstGeom prst="rect">
+            <a:avLst/>
+          </a:prstGeom>
+          <a:noFill/>
+          <a:ln/>
+        </p:spPr>
+        <p:txBody>
+          <a:bodyPr wrap="square" lIns="0" tIns="0" rIns="0" bIns="0" rtlCol="0" anchor="t"/>
+          <a:lstStyle/>
+          <a:p>
+            <a:pPr indent="0" marL="0">
+              <a:buNone/>
+            </a:pPr>
+            <a:r>
+              <a:rPr lang="en-US" sz="2200" b="1" dirty="0">
+                <a:solidFill>
+                  <a:schemeClr val="bg1"/>
+                </a:solidFill>
+                <a:latin typeface="Cambria" pitchFamily="34" charset="0"/>
+                <a:ea typeface="Cambria" pitchFamily="34" charset="-122"/>
+                <a:cs typeface="Cambria" pitchFamily="34" charset="-120"/>
+              </a:rPr>
+              <a:t>Write the project's main question in one sentence</a:t>
+            </a:r>
+            <a:endParaRPr lang="en-US" sz="2200" dirty="0"/>
+          </a:p>
+        </p:txBody>
+      </p:sp>
+      <p:sp>
+        <p:nvSpPr>
+          <p:cNvPr id="8" name="Question 1 card"/>
+          <p:cNvSpPr/>
+          <p:nvPr/>
+        </p:nvSpPr>
+        <p:spPr>
+          <a:xfrm>
+            <a:off x="4343400" y="1508760"/>
+            <a:ext cx="7296912" cy="868680"/>
+          </a:xfrm>
+          <a:prstGeom prst="roundRect">
+            <a:avLst>
+              <a:gd name="adj" fmla="val 10526"/>
             </a:avLst>
           </a:prstGeom>
           <a:solidFill>
@@ -2976,14 +3224,14 @@
       </p:sp>
       <p:sp>
         <p:nvSpPr>
-          <p:cNvPr id="4" name="Shape 2"/>
+          <p:cNvPr id="9" name="Shape 6"/>
           <p:cNvSpPr/>
           <p:nvPr/>
         </p:nvSpPr>
         <p:spPr>
           <a:xfrm>
-            <a:off x="868680" y="1965960"/>
-            <a:ext cx="731520" cy="731520"/>
+            <a:off x="4572000" y="1668780"/>
+            <a:ext cx="548640" cy="548640"/>
           </a:xfrm>
           <a:prstGeom prst="ellipse">
             <a:avLst/>
@@ -2996,14 +3244,14 @@
       </p:sp>
       <p:sp>
         <p:nvSpPr>
-          <p:cNvPr id="5" name="Text 3"/>
+          <p:cNvPr id="10" name="Text 7"/>
           <p:cNvSpPr txBox="1"/>
           <p:nvPr/>
         </p:nvSpPr>
         <p:spPr>
           <a:xfrm>
-            <a:off x="868680" y="1965960"/>
-            <a:ext cx="731520" cy="731520"/>
+            <a:off x="4572000" y="1668780"/>
+            <a:ext cx="548640" cy="548640"/>
           </a:xfrm>
           <a:prstGeom prst="rect">
             <a:avLst/>
@@ -3019,7 +3267,7 @@
               <a:buNone/>
             </a:pPr>
             <a:r>
-              <a:rPr lang="en-US" sz="2800" b="1" dirty="0">
+              <a:rPr lang="en-US" sz="2000" b="1" dirty="0">
                 <a:solidFill>
                   <a:schemeClr val="bg1"/>
                 </a:solidFill>
@@ -3029,20 +3277,20 @@
               </a:rPr>
               <a:t>1</a:t>
             </a:r>
-            <a:endParaRPr lang="en-US" sz="2800" dirty="0"/>
-          </a:p>
-        </p:txBody>
-      </p:sp>
-      <p:sp>
-        <p:nvSpPr>
-          <p:cNvPr id="6" name="Text 4"/>
+            <a:endParaRPr lang="en-US" sz="2000" dirty="0"/>
+          </a:p>
+        </p:txBody>
+      </p:sp>
+      <p:sp>
+        <p:nvSpPr>
+          <p:cNvPr id="11" name="Text 8"/>
           <p:cNvSpPr txBox="1"/>
           <p:nvPr/>
         </p:nvSpPr>
         <p:spPr>
           <a:xfrm>
-            <a:off x="868680" y="2926080"/>
-            <a:ext cx="2889504" cy="731520"/>
+            <a:off x="5349240" y="1600200"/>
+            <a:ext cx="6062472" cy="685800"/>
           </a:xfrm>
           <a:prstGeom prst="rect">
             <a:avLst/>
@@ -3051,14 +3299,14 @@
           <a:ln/>
         </p:spPr>
         <p:txBody>
-          <a:bodyPr wrap="square" lIns="0" tIns="0" rIns="0" bIns="0" rtlCol="0" anchor="t"/>
+          <a:bodyPr wrap="square" lIns="0" tIns="0" rIns="0" bIns="0" rtlCol="0" anchor="ctr"/>
           <a:lstStyle/>
           <a:p>
             <a:pPr indent="0" marL="0">
               <a:buNone/>
             </a:pPr>
             <a:r>
-              <a:rPr lang="en-US" sz="2200" b="1" dirty="0">
+              <a:rPr lang="en-US" sz="1800" b="1" dirty="0">
                 <a:solidFill>
                   <a:schemeClr val="tx1"/>
                 </a:solidFill>
@@ -3068,60 +3316,38 @@
               </a:rPr>
               <a:t>Groundwater levels</a:t>
             </a:r>
-            <a:endParaRPr lang="en-US" sz="2200" dirty="0"/>
-          </a:p>
-        </p:txBody>
-      </p:sp>
-      <p:sp>
-        <p:nvSpPr>
-          <p:cNvPr id="7" name="Text 5"/>
-          <p:cNvSpPr txBox="1"/>
-          <p:nvPr/>
-        </p:nvSpPr>
-        <p:spPr>
-          <a:xfrm>
-            <a:off x="868680" y="3886200"/>
-            <a:ext cx="2889504" cy="1645920"/>
-          </a:xfrm>
-          <a:prstGeom prst="rect">
-            <a:avLst/>
-          </a:prstGeom>
-          <a:noFill/>
-          <a:ln/>
-        </p:spPr>
-        <p:txBody>
-          <a:bodyPr wrap="square" lIns="0" tIns="0" rIns="0" bIns="0" rtlCol="0" anchor="t"/>
-          <a:lstStyle/>
+            <a:endParaRPr lang="en-US" sz="1800" dirty="0"/>
+          </a:p>
           <a:p>
             <a:pPr indent="0" marL="0">
               <a:buNone/>
             </a:pPr>
             <a:r>
-              <a:rPr lang="en-US" sz="1600" dirty="0">
+              <a:rPr lang="en-US" sz="1400" dirty="0">
                 <a:solidFill>
                   <a:schemeClr val="tx2"/>
                 </a:solidFill>
               </a:rPr>
               <a:t>Write the question in one sentence, using the wording from the proposal.</a:t>
             </a:r>
-            <a:endParaRPr lang="en-US" sz="1600" dirty="0"/>
-          </a:p>
-        </p:txBody>
-      </p:sp>
-      <p:sp>
-        <p:nvSpPr>
-          <p:cNvPr id="8" name="Question 2 card"/>
+            <a:endParaRPr lang="en-US" sz="1800" dirty="0"/>
+          </a:p>
+        </p:txBody>
+      </p:sp>
+      <p:sp>
+        <p:nvSpPr>
+          <p:cNvPr id="12" name="Question 2 card"/>
           <p:cNvSpPr/>
           <p:nvPr/>
         </p:nvSpPr>
         <p:spPr>
           <a:xfrm>
-            <a:off x="4334256" y="1600200"/>
-            <a:ext cx="3529584" cy="4206240"/>
+            <a:off x="4343400" y="2560320"/>
+            <a:ext cx="7296912" cy="868680"/>
           </a:xfrm>
           <a:prstGeom prst="roundRect">
             <a:avLst>
-              <a:gd name="adj" fmla="val 3109"/>
+              <a:gd name="adj" fmla="val 10526"/>
             </a:avLst>
           </a:prstGeom>
           <a:solidFill>
@@ -3132,14 +3358,14 @@
       </p:sp>
       <p:sp>
         <p:nvSpPr>
-          <p:cNvPr id="9" name="Shape 7"/>
+          <p:cNvPr id="13" name="Shape 10"/>
           <p:cNvSpPr/>
           <p:nvPr/>
         </p:nvSpPr>
         <p:spPr>
           <a:xfrm>
-            <a:off x="4654296" y="1965960"/>
-            <a:ext cx="731520" cy="731520"/>
+            <a:off x="4572000" y="2720340"/>
+            <a:ext cx="548640" cy="548640"/>
           </a:xfrm>
           <a:prstGeom prst="ellipse">
             <a:avLst/>
@@ -3152,14 +3378,14 @@
       </p:sp>
       <p:sp>
         <p:nvSpPr>
-          <p:cNvPr id="10" name="Text 8"/>
+          <p:cNvPr id="14" name="Text 11"/>
           <p:cNvSpPr txBox="1"/>
           <p:nvPr/>
         </p:nvSpPr>
         <p:spPr>
           <a:xfrm>
-            <a:off x="4654296" y="1965960"/>
-            <a:ext cx="731520" cy="731520"/>
+            <a:off x="4572000" y="2720340"/>
+            <a:ext cx="548640" cy="548640"/>
           </a:xfrm>
           <a:prstGeom prst="rect">
             <a:avLst/>
@@ -3175,7 +3401,7 @@
               <a:buNone/>
             </a:pPr>
             <a:r>
-              <a:rPr lang="en-US" sz="2800" b="1" dirty="0">
+              <a:rPr lang="en-US" sz="2000" b="1" dirty="0">
                 <a:solidFill>
                   <a:schemeClr val="bg1"/>
                 </a:solidFill>
@@ -3185,20 +3411,20 @@
               </a:rPr>
               <a:t>2</a:t>
             </a:r>
-            <a:endParaRPr lang="en-US" sz="2800" dirty="0"/>
-          </a:p>
-        </p:txBody>
-      </p:sp>
-      <p:sp>
-        <p:nvSpPr>
-          <p:cNvPr id="11" name="Text 9"/>
+            <a:endParaRPr lang="en-US" sz="2000" dirty="0"/>
+          </a:p>
+        </p:txBody>
+      </p:sp>
+      <p:sp>
+        <p:nvSpPr>
+          <p:cNvPr id="15" name="Text 12"/>
           <p:cNvSpPr txBox="1"/>
           <p:nvPr/>
         </p:nvSpPr>
         <p:spPr>
           <a:xfrm>
-            <a:off x="4654296" y="2926080"/>
-            <a:ext cx="2889504" cy="731520"/>
+            <a:off x="5349240" y="2651760"/>
+            <a:ext cx="6062472" cy="685800"/>
           </a:xfrm>
           <a:prstGeom prst="rect">
             <a:avLst/>
@@ -3207,14 +3433,14 @@
           <a:ln/>
         </p:spPr>
         <p:txBody>
-          <a:bodyPr wrap="square" lIns="0" tIns="0" rIns="0" bIns="0" rtlCol="0" anchor="t"/>
+          <a:bodyPr wrap="square" lIns="0" tIns="0" rIns="0" bIns="0" rtlCol="0" anchor="ctr"/>
           <a:lstStyle/>
           <a:p>
             <a:pPr indent="0" marL="0">
               <a:buNone/>
             </a:pPr>
             <a:r>
-              <a:rPr lang="en-US" sz="2200" b="1" dirty="0">
+              <a:rPr lang="en-US" sz="1800" b="1" dirty="0">
                 <a:solidFill>
                   <a:schemeClr val="tx1"/>
                 </a:solidFill>
@@ -3224,60 +3450,38 @@
               </a:rPr>
               <a:t>Cuba's aquifers</a:t>
             </a:r>
-            <a:endParaRPr lang="en-US" sz="2200" dirty="0"/>
-          </a:p>
-        </p:txBody>
-      </p:sp>
-      <p:sp>
-        <p:nvSpPr>
-          <p:cNvPr id="12" name="Text 10"/>
-          <p:cNvSpPr txBox="1"/>
-          <p:nvPr/>
-        </p:nvSpPr>
-        <p:spPr>
-          <a:xfrm>
-            <a:off x="4654296" y="3886200"/>
-            <a:ext cx="2889504" cy="1645920"/>
-          </a:xfrm>
-          <a:prstGeom prst="rect">
-            <a:avLst/>
-          </a:prstGeom>
-          <a:noFill/>
-          <a:ln/>
-        </p:spPr>
-        <p:txBody>
-          <a:bodyPr wrap="square" lIns="0" tIns="0" rIns="0" bIns="0" rtlCol="0" anchor="t"/>
-          <a:lstStyle/>
+            <a:endParaRPr lang="en-US" sz="1800" dirty="0"/>
+          </a:p>
           <a:p>
             <a:pPr indent="0" marL="0">
               <a:buNone/>
             </a:pPr>
             <a:r>
-              <a:rPr lang="en-US" sz="1600" dirty="0">
+              <a:rPr lang="en-US" sz="1400" dirty="0">
                 <a:solidFill>
                   <a:schemeClr val="tx2"/>
                 </a:solidFill>
               </a:rPr>
               <a:t>Write the question in one sentence, using the wording from the proposal.</a:t>
             </a:r>
-            <a:endParaRPr lang="en-US" sz="1600" dirty="0"/>
-          </a:p>
-        </p:txBody>
-      </p:sp>
-      <p:sp>
-        <p:nvSpPr>
-          <p:cNvPr id="13" name="Question 3 card"/>
+            <a:endParaRPr lang="en-US" sz="1800" dirty="0"/>
+          </a:p>
+        </p:txBody>
+      </p:sp>
+      <p:sp>
+        <p:nvSpPr>
+          <p:cNvPr id="16" name="Question 3 card"/>
           <p:cNvSpPr/>
           <p:nvPr/>
         </p:nvSpPr>
         <p:spPr>
           <a:xfrm>
-            <a:off x="8119872" y="1600200"/>
-            <a:ext cx="3529584" cy="4206240"/>
+            <a:off x="4343400" y="3611880"/>
+            <a:ext cx="7296912" cy="868680"/>
           </a:xfrm>
           <a:prstGeom prst="roundRect">
             <a:avLst>
-              <a:gd name="adj" fmla="val 3109"/>
+              <a:gd name="adj" fmla="val 10526"/>
             </a:avLst>
           </a:prstGeom>
           <a:solidFill>
@@ -3288,14 +3492,14 @@
       </p:sp>
       <p:sp>
         <p:nvSpPr>
-          <p:cNvPr id="14" name="Shape 12"/>
+          <p:cNvPr id="17" name="Shape 14"/>
           <p:cNvSpPr/>
           <p:nvPr/>
         </p:nvSpPr>
         <p:spPr>
           <a:xfrm>
-            <a:off x="8439912" y="1965960"/>
-            <a:ext cx="731520" cy="731520"/>
+            <a:off x="4572000" y="3771900"/>
+            <a:ext cx="548640" cy="548640"/>
           </a:xfrm>
           <a:prstGeom prst="ellipse">
             <a:avLst/>
@@ -3308,14 +3512,14 @@
       </p:sp>
       <p:sp>
         <p:nvSpPr>
-          <p:cNvPr id="15" name="Text 13"/>
+          <p:cNvPr id="18" name="Text 15"/>
           <p:cNvSpPr txBox="1"/>
           <p:nvPr/>
         </p:nvSpPr>
         <p:spPr>
           <a:xfrm>
-            <a:off x="8439912" y="1965960"/>
-            <a:ext cx="731520" cy="731520"/>
+            <a:off x="4572000" y="3771900"/>
+            <a:ext cx="548640" cy="548640"/>
           </a:xfrm>
           <a:prstGeom prst="rect">
             <a:avLst/>
@@ -3331,7 +3535,7 @@
               <a:buNone/>
             </a:pPr>
             <a:r>
-              <a:rPr lang="en-US" sz="2800" b="1" dirty="0">
+              <a:rPr lang="en-US" sz="2000" b="1" dirty="0">
                 <a:solidFill>
                   <a:schemeClr val="bg1"/>
                 </a:solidFill>
@@ -3341,20 +3545,20 @@
               </a:rPr>
               <a:t>3</a:t>
             </a:r>
-            <a:endParaRPr lang="en-US" sz="2800" dirty="0"/>
-          </a:p>
-        </p:txBody>
-      </p:sp>
-      <p:sp>
-        <p:nvSpPr>
-          <p:cNvPr id="16" name="Text 14"/>
+            <a:endParaRPr lang="en-US" sz="2000" dirty="0"/>
+          </a:p>
+        </p:txBody>
+      </p:sp>
+      <p:sp>
+        <p:nvSpPr>
+          <p:cNvPr id="19" name="Text 16"/>
           <p:cNvSpPr txBox="1"/>
           <p:nvPr/>
         </p:nvSpPr>
         <p:spPr>
           <a:xfrm>
-            <a:off x="8439912" y="2926080"/>
-            <a:ext cx="2889504" cy="731520"/>
+            <a:off x="5349240" y="3703320"/>
+            <a:ext cx="6062472" cy="685800"/>
           </a:xfrm>
           <a:prstGeom prst="rect">
             <a:avLst/>
@@ -3363,14 +3567,14 @@
           <a:ln/>
         </p:spPr>
         <p:txBody>
-          <a:bodyPr wrap="square" lIns="0" tIns="0" rIns="0" bIns="0" rtlCol="0" anchor="t"/>
+          <a:bodyPr wrap="square" lIns="0" tIns="0" rIns="0" bIns="0" rtlCol="0" anchor="ctr"/>
           <a:lstStyle/>
           <a:p>
             <a:pPr indent="0" marL="0">
               <a:buNone/>
             </a:pPr>
             <a:r>
-              <a:rPr lang="en-US" sz="2200" b="1" dirty="0">
+              <a:rPr lang="en-US" sz="1800" b="1" dirty="0">
                 <a:solidFill>
                   <a:schemeClr val="tx1"/>
                 </a:solidFill>
@@ -3380,43 +3584,21 @@
               </a:rPr>
               <a:t>Water quality and acequias</a:t>
             </a:r>
-            <a:endParaRPr lang="en-US" sz="2200" dirty="0"/>
-          </a:p>
-        </p:txBody>
-      </p:sp>
-      <p:sp>
-        <p:nvSpPr>
-          <p:cNvPr id="17" name="Text 15"/>
-          <p:cNvSpPr txBox="1"/>
-          <p:nvPr/>
-        </p:nvSpPr>
-        <p:spPr>
-          <a:xfrm>
-            <a:off x="8439912" y="3886200"/>
-            <a:ext cx="2889504" cy="1645920"/>
-          </a:xfrm>
-          <a:prstGeom prst="rect">
-            <a:avLst/>
-          </a:prstGeom>
-          <a:noFill/>
-          <a:ln/>
-        </p:spPr>
-        <p:txBody>
-          <a:bodyPr wrap="square" lIns="0" tIns="0" rIns="0" bIns="0" rtlCol="0" anchor="t"/>
-          <a:lstStyle/>
+            <a:endParaRPr lang="en-US" sz="1800" dirty="0"/>
+          </a:p>
           <a:p>
             <a:pPr indent="0" marL="0">
               <a:buNone/>
             </a:pPr>
             <a:r>
-              <a:rPr lang="en-US" sz="1600" dirty="0">
+              <a:rPr lang="en-US" sz="1400" dirty="0">
                 <a:solidFill>
                   <a:schemeClr val="tx2"/>
                 </a:solidFill>
               </a:rPr>
               <a:t>Write the question in one sentence, using the wording from the proposal.</a:t>
             </a:r>
-            <a:endParaRPr lang="en-US" sz="1600" dirty="0"/>
+            <a:endParaRPr lang="en-US" sz="1800" dirty="0"/>
           </a:p>
         </p:txBody>
       </p:sp>
@@ -3432,8 +3614,8 @@
         </p:nvSpPr>
         <p:spPr>
           <a:xfrm>
-            <a:off x="11091672" y="6318504"/>
-            <a:ext cx="548640" cy="329184"/>
+            <a:off x="548640" y="6400800"/>
+            <a:ext cx="365760" cy="292608"/>
           </a:xfrm>
           <a:prstGeom prst="rect">
             <a:avLst/>
@@ -3445,20 +3627,20 @@
           </a:extLst>
         </p:spPr>
         <p:txBody>
-          <a:bodyPr anchor="ctr"/>
+          <a:bodyPr lIns="0" tIns="0" rIns="0" bIns="0" anchor="ctr"/>
           <a:lstStyle>
             <a:lvl1pPr>
               <a:defRPr sz="1000">
                 <a:solidFill>
-                  <a:schemeClr val="accent6"/>
+                  <a:schemeClr val="bg1"/>
                 </a:solidFill>
               </a:defRPr>
             </a:lvl1pPr>
           </a:lstStyle>
           <a:p>
-            <a:pPr algn="r"/>
+            <a:pPr algn="l"/>
             <a:fld id="{F7021451-1387-4CA6-816F-3879F97B5CBC}" type="slidenum">
-              <a:rPr b="0" lang="en-US"/>
+              <a:rPr b="1" lang="en-US"/>
               <a:t>3</a:t>
             </a:fld>
             <a:endParaRPr lang="en-US"/>
@@ -3500,8 +3682,8 @@
         </p:nvSpPr>
         <p:spPr>
           <a:xfrm>
-            <a:off x="548640" y="411480"/>
-            <a:ext cx="11091672" cy="822960"/>
+            <a:off x="548640" y="182880"/>
+            <a:ext cx="7315200" cy="822960"/>
           </a:xfrm>
           <a:prstGeom prst="rect">
             <a:avLst/>
@@ -3519,7 +3701,7 @@
             <a:r>
               <a:rPr lang="en-US" sz="3600" b="1" dirty="0">
                 <a:solidFill>
-                  <a:schemeClr val="tx1"/>
+                  <a:schemeClr val="bg1"/>
                 </a:solidFill>
               </a:rPr>
               <a:t>Data</a:t>
@@ -3536,12 +3718,12 @@
         </p:nvSpPr>
         <p:spPr>
           <a:xfrm>
-            <a:off x="548640" y="1600200"/>
-            <a:ext cx="5413248" cy="2011680"/>
+            <a:off x="548640" y="1508760"/>
+            <a:ext cx="2560320" cy="2834640"/>
           </a:xfrm>
           <a:prstGeom prst="roundRect">
             <a:avLst>
-              <a:gd name="adj" fmla="val 5455"/>
+              <a:gd name="adj" fmla="val 4286"/>
             </a:avLst>
           </a:prstGeom>
           <a:solidFill>
@@ -3558,8 +3740,8 @@
         </p:nvSpPr>
         <p:spPr>
           <a:xfrm>
-            <a:off x="868680" y="1965960"/>
-            <a:ext cx="822960" cy="822960"/>
+            <a:off x="822960" y="1783080"/>
+            <a:ext cx="731520" cy="731520"/>
           </a:xfrm>
           <a:prstGeom prst="ellipse">
             <a:avLst/>
@@ -3586,8 +3768,8 @@
         </p:blipFill>
         <p:spPr>
           <a:xfrm>
-            <a:off x="1074420" y="2171700"/>
-            <a:ext cx="411480" cy="411480"/>
+            <a:off x="1005840" y="1965960"/>
+            <a:ext cx="365760" cy="365760"/>
           </a:xfrm>
           <a:prstGeom prst="rect">
             <a:avLst/>
@@ -3602,8 +3784,8 @@
         </p:nvSpPr>
         <p:spPr>
           <a:xfrm>
-            <a:off x="1965960" y="1965960"/>
-            <a:ext cx="3675888" cy="457200"/>
+            <a:off x="822960" y="2697480"/>
+            <a:ext cx="2011680" cy="685800"/>
           </a:xfrm>
           <a:prstGeom prst="rect">
             <a:avLst/>
@@ -3612,14 +3794,14 @@
           <a:ln/>
         </p:spPr>
         <p:txBody>
-          <a:bodyPr wrap="square" lIns="0" tIns="0" rIns="0" bIns="0" rtlCol="0" anchor="ctr"/>
+          <a:bodyPr wrap="square" lIns="0" tIns="0" rIns="0" bIns="0" rtlCol="0" anchor="t"/>
           <a:lstStyle/>
           <a:p>
             <a:pPr indent="0" marL="0">
               <a:buNone/>
             </a:pPr>
             <a:r>
-              <a:rPr lang="en-US" sz="2200" b="1" dirty="0">
+              <a:rPr lang="en-US" sz="2000" b="1" dirty="0">
                 <a:solidFill>
                   <a:schemeClr val="tx1"/>
                 </a:solidFill>
@@ -3629,7 +3811,7 @@
               </a:rPr>
               <a:t>Groundwater levels</a:t>
             </a:r>
-            <a:endParaRPr lang="en-US" sz="2200" dirty="0"/>
+            <a:endParaRPr lang="en-US" sz="2000" dirty="0"/>
           </a:p>
         </p:txBody>
       </p:sp>
@@ -3641,8 +3823,8 @@
         </p:nvSpPr>
         <p:spPr>
           <a:xfrm>
-            <a:off x="1965960" y="2496312"/>
-            <a:ext cx="3675888" cy="822960"/>
+            <a:off x="822960" y="3383280"/>
+            <a:ext cx="2011680" cy="822960"/>
           </a:xfrm>
           <a:prstGeom prst="rect">
             <a:avLst/>
@@ -3658,14 +3840,14 @@
               <a:buNone/>
             </a:pPr>
             <a:r>
-              <a:rPr lang="en-US" sz="1600" dirty="0">
+              <a:rPr lang="en-US" sz="1400" dirty="0">
                 <a:solidFill>
                   <a:schemeClr val="tx2"/>
                 </a:solidFill>
               </a:rPr>
               <a:t>Source, years covered, and number of sites</a:t>
             </a:r>
-            <a:endParaRPr lang="en-US" sz="1600" dirty="0"/>
+            <a:endParaRPr lang="en-US" sz="1400" dirty="0"/>
           </a:p>
         </p:txBody>
       </p:sp>
@@ -3677,12 +3859,12 @@
         </p:nvSpPr>
         <p:spPr>
           <a:xfrm>
-            <a:off x="6236208" y="1600200"/>
-            <a:ext cx="5413248" cy="2011680"/>
+            <a:off x="3383280" y="1508760"/>
+            <a:ext cx="2560320" cy="2834640"/>
           </a:xfrm>
           <a:prstGeom prst="roundRect">
             <a:avLst>
-              <a:gd name="adj" fmla="val 5455"/>
+              <a:gd name="adj" fmla="val 4286"/>
             </a:avLst>
           </a:prstGeom>
           <a:solidFill>
@@ -3699,8 +3881,8 @@
         </p:nvSpPr>
         <p:spPr>
           <a:xfrm>
-            <a:off x="6556248" y="1965960"/>
-            <a:ext cx="822960" cy="822960"/>
+            <a:off x="3657600" y="1783080"/>
+            <a:ext cx="731520" cy="731520"/>
           </a:xfrm>
           <a:prstGeom prst="ellipse">
             <a:avLst/>
@@ -3727,8 +3909,8 @@
         </p:blipFill>
         <p:spPr>
           <a:xfrm>
-            <a:off x="6761988" y="2171700"/>
-            <a:ext cx="411480" cy="411480"/>
+            <a:off x="3840480" y="1965960"/>
+            <a:ext cx="365760" cy="365760"/>
           </a:xfrm>
           <a:prstGeom prst="rect">
             <a:avLst/>
@@ -3743,8 +3925,8 @@
         </p:nvSpPr>
         <p:spPr>
           <a:xfrm>
-            <a:off x="7653528" y="1965960"/>
-            <a:ext cx="3675888" cy="457200"/>
+            <a:off x="3657600" y="2697480"/>
+            <a:ext cx="2011680" cy="685800"/>
           </a:xfrm>
           <a:prstGeom prst="rect">
             <a:avLst/>
@@ -3753,14 +3935,14 @@
           <a:ln/>
         </p:spPr>
         <p:txBody>
-          <a:bodyPr wrap="square" lIns="0" tIns="0" rIns="0" bIns="0" rtlCol="0" anchor="ctr"/>
+          <a:bodyPr wrap="square" lIns="0" tIns="0" rIns="0" bIns="0" rtlCol="0" anchor="t"/>
           <a:lstStyle/>
           <a:p>
             <a:pPr indent="0" marL="0">
               <a:buNone/>
             </a:pPr>
             <a:r>
-              <a:rPr lang="en-US" sz="2200" b="1" dirty="0">
+              <a:rPr lang="en-US" sz="2000" b="1" dirty="0">
                 <a:solidFill>
                   <a:schemeClr val="tx1"/>
                 </a:solidFill>
@@ -3770,7 +3952,7 @@
               </a:rPr>
               <a:t>Aquifer tests</a:t>
             </a:r>
-            <a:endParaRPr lang="en-US" sz="2200" dirty="0"/>
+            <a:endParaRPr lang="en-US" sz="2000" dirty="0"/>
           </a:p>
         </p:txBody>
       </p:sp>
@@ -3782,8 +3964,8 @@
         </p:nvSpPr>
         <p:spPr>
           <a:xfrm>
-            <a:off x="7653528" y="2496312"/>
-            <a:ext cx="3675888" cy="822960"/>
+            <a:off x="3657600" y="3383280"/>
+            <a:ext cx="2011680" cy="822960"/>
           </a:xfrm>
           <a:prstGeom prst="rect">
             <a:avLst/>
@@ -3799,14 +3981,14 @@
               <a:buNone/>
             </a:pPr>
             <a:r>
-              <a:rPr lang="en-US" sz="1600" dirty="0">
+              <a:rPr lang="en-US" sz="1400" dirty="0">
                 <a:solidFill>
                   <a:schemeClr val="tx2"/>
                 </a:solidFill>
               </a:rPr>
               <a:t>Source, years covered, and number of sites</a:t>
             </a:r>
-            <a:endParaRPr lang="en-US" sz="1600" dirty="0"/>
+            <a:endParaRPr lang="en-US" sz="1400" dirty="0"/>
           </a:p>
         </p:txBody>
       </p:sp>
@@ -3818,12 +4000,12 @@
         </p:nvSpPr>
         <p:spPr>
           <a:xfrm>
-            <a:off x="548640" y="3886200"/>
-            <a:ext cx="5413248" cy="2011680"/>
+            <a:off x="6217920" y="1508760"/>
+            <a:ext cx="2560320" cy="2834640"/>
           </a:xfrm>
           <a:prstGeom prst="roundRect">
             <a:avLst>
-              <a:gd name="adj" fmla="val 5455"/>
+              <a:gd name="adj" fmla="val 4286"/>
             </a:avLst>
           </a:prstGeom>
           <a:solidFill>
@@ -3840,8 +4022,8 @@
         </p:nvSpPr>
         <p:spPr>
           <a:xfrm>
-            <a:off x="868680" y="4251960"/>
-            <a:ext cx="822960" cy="822960"/>
+            <a:off x="6492240" y="1783080"/>
+            <a:ext cx="731520" cy="731520"/>
           </a:xfrm>
           <a:prstGeom prst="ellipse">
             <a:avLst/>
@@ -3868,8 +4050,8 @@
         </p:blipFill>
         <p:spPr>
           <a:xfrm>
-            <a:off x="1074420" y="4457700"/>
-            <a:ext cx="411480" cy="411480"/>
+            <a:off x="6675120" y="1965960"/>
+            <a:ext cx="365760" cy="365760"/>
           </a:xfrm>
           <a:prstGeom prst="rect">
             <a:avLst/>
@@ -3884,8 +4066,8 @@
         </p:nvSpPr>
         <p:spPr>
           <a:xfrm>
-            <a:off x="1965960" y="4251960"/>
-            <a:ext cx="3675888" cy="457200"/>
+            <a:off x="6492240" y="2697480"/>
+            <a:ext cx="2011680" cy="685800"/>
           </a:xfrm>
           <a:prstGeom prst="rect">
             <a:avLst/>
@@ -3894,14 +4076,14 @@
           <a:ln/>
         </p:spPr>
         <p:txBody>
-          <a:bodyPr wrap="square" lIns="0" tIns="0" rIns="0" bIns="0" rtlCol="0" anchor="ctr"/>
+          <a:bodyPr wrap="square" lIns="0" tIns="0" rIns="0" bIns="0" rtlCol="0" anchor="t"/>
           <a:lstStyle/>
           <a:p>
             <a:pPr indent="0" marL="0">
               <a:buNone/>
             </a:pPr>
             <a:r>
-              <a:rPr lang="en-US" sz="2200" b="1" dirty="0">
+              <a:rPr lang="en-US" sz="2000" b="1" dirty="0">
                 <a:solidFill>
                   <a:schemeClr val="tx1"/>
                 </a:solidFill>
@@ -3911,7 +4093,7 @@
               </a:rPr>
               <a:t>Water quality</a:t>
             </a:r>
-            <a:endParaRPr lang="en-US" sz="2200" dirty="0"/>
+            <a:endParaRPr lang="en-US" sz="2000" dirty="0"/>
           </a:p>
         </p:txBody>
       </p:sp>
@@ -3923,8 +4105,8 @@
         </p:nvSpPr>
         <p:spPr>
           <a:xfrm>
-            <a:off x="1965960" y="4782312"/>
-            <a:ext cx="3675888" cy="822960"/>
+            <a:off x="6492240" y="3383280"/>
+            <a:ext cx="2011680" cy="822960"/>
           </a:xfrm>
           <a:prstGeom prst="rect">
             <a:avLst/>
@@ -3940,14 +4122,14 @@
               <a:buNone/>
             </a:pPr>
             <a:r>
-              <a:rPr lang="en-US" sz="1600" dirty="0">
+              <a:rPr lang="en-US" sz="1400" dirty="0">
                 <a:solidFill>
                   <a:schemeClr val="tx2"/>
                 </a:solidFill>
               </a:rPr>
               <a:t>Source, years covered, and number of sites</a:t>
             </a:r>
-            <a:endParaRPr lang="en-US" sz="1600" dirty="0"/>
+            <a:endParaRPr lang="en-US" sz="1400" dirty="0"/>
           </a:p>
         </p:txBody>
       </p:sp>
@@ -3959,12 +4141,12 @@
         </p:nvSpPr>
         <p:spPr>
           <a:xfrm>
-            <a:off x="6236208" y="3886200"/>
-            <a:ext cx="5413248" cy="2011680"/>
+            <a:off x="9052560" y="1508760"/>
+            <a:ext cx="2560320" cy="2834640"/>
           </a:xfrm>
           <a:prstGeom prst="roundRect">
             <a:avLst>
-              <a:gd name="adj" fmla="val 5455"/>
+              <a:gd name="adj" fmla="val 4286"/>
             </a:avLst>
           </a:prstGeom>
           <a:solidFill>
@@ -3981,8 +4163,8 @@
         </p:nvSpPr>
         <p:spPr>
           <a:xfrm>
-            <a:off x="6556248" y="4251960"/>
-            <a:ext cx="822960" cy="822960"/>
+            <a:off x="9326880" y="1783080"/>
+            <a:ext cx="731520" cy="731520"/>
           </a:xfrm>
           <a:prstGeom prst="ellipse">
             <a:avLst/>
@@ -4009,8 +4191,8 @@
         </p:blipFill>
         <p:spPr>
           <a:xfrm>
-            <a:off x="6761988" y="4457700"/>
-            <a:ext cx="411480" cy="411480"/>
+            <a:off x="9509760" y="1965960"/>
+            <a:ext cx="365760" cy="365760"/>
           </a:xfrm>
           <a:prstGeom prst="rect">
             <a:avLst/>
@@ -4025,8 +4207,8 @@
         </p:nvSpPr>
         <p:spPr>
           <a:xfrm>
-            <a:off x="7653528" y="4251960"/>
-            <a:ext cx="3675888" cy="457200"/>
+            <a:off x="9326880" y="2697480"/>
+            <a:ext cx="2011680" cy="685800"/>
           </a:xfrm>
           <a:prstGeom prst="rect">
             <a:avLst/>
@@ -4035,14 +4217,14 @@
           <a:ln/>
         </p:spPr>
         <p:txBody>
-          <a:bodyPr wrap="square" lIns="0" tIns="0" rIns="0" bIns="0" rtlCol="0" anchor="ctr"/>
+          <a:bodyPr wrap="square" lIns="0" tIns="0" rIns="0" bIns="0" rtlCol="0" anchor="t"/>
           <a:lstStyle/>
           <a:p>
             <a:pPr indent="0" marL="0">
               <a:buNone/>
             </a:pPr>
             <a:r>
-              <a:rPr lang="en-US" sz="2200" b="1" dirty="0">
+              <a:rPr lang="en-US" sz="2000" b="1" dirty="0">
                 <a:solidFill>
                   <a:schemeClr val="tx1"/>
                 </a:solidFill>
@@ -4052,7 +4234,7 @@
               </a:rPr>
               <a:t>Acequias</a:t>
             </a:r>
-            <a:endParaRPr lang="en-US" sz="2200" dirty="0"/>
+            <a:endParaRPr lang="en-US" sz="2000" dirty="0"/>
           </a:p>
         </p:txBody>
       </p:sp>
@@ -4064,8 +4246,8 @@
         </p:nvSpPr>
         <p:spPr>
           <a:xfrm>
-            <a:off x="7653528" y="4782312"/>
-            <a:ext cx="3675888" cy="822960"/>
+            <a:off x="9326880" y="3383280"/>
+            <a:ext cx="2011680" cy="822960"/>
           </a:xfrm>
           <a:prstGeom prst="rect">
             <a:avLst/>
@@ -4081,14 +4263,50 @@
               <a:buNone/>
             </a:pPr>
             <a:r>
-              <a:rPr lang="en-US" sz="1600" dirty="0">
+              <a:rPr lang="en-US" sz="1400" dirty="0">
                 <a:solidFill>
                   <a:schemeClr val="tx2"/>
                 </a:solidFill>
               </a:rPr>
               <a:t>Source, years covered, and number of sites</a:t>
             </a:r>
-            <a:endParaRPr lang="en-US" sz="1600" dirty="0"/>
+            <a:endParaRPr lang="en-US" sz="1400" dirty="0"/>
+          </a:p>
+        </p:txBody>
+      </p:sp>
+      <p:sp>
+        <p:nvSpPr>
+          <p:cNvPr id="23" name="Caption"/>
+          <p:cNvSpPr txBox="1"/>
+          <p:nvPr/>
+        </p:nvSpPr>
+        <p:spPr>
+          <a:xfrm>
+            <a:off x="548640" y="4572000"/>
+            <a:ext cx="8961120" cy="320040"/>
+          </a:xfrm>
+          <a:prstGeom prst="rect">
+            <a:avLst/>
+          </a:prstGeom>
+          <a:noFill/>
+          <a:ln/>
+        </p:spPr>
+        <p:txBody>
+          <a:bodyPr wrap="square" lIns="0" tIns="0" rIns="0" bIns="0" rtlCol="0" anchor="t"/>
+          <a:lstStyle/>
+          <a:p>
+            <a:pPr indent="0" marL="0">
+              <a:buNone/>
+            </a:pPr>
+            <a:r>
+              <a:rPr lang="en-US" sz="1200" i="1" dirty="0">
+                <a:solidFill>
+                  <a:schemeClr val="accent6"/>
+                </a:solidFill>
+              </a:rPr>
+              <a:t>Full source links are on the last slide and in the project documentation.</a:t>
+            </a:r>
+            <a:endParaRPr lang="en-US" sz="1200" dirty="0"/>
           </a:p>
         </p:txBody>
       </p:sp>
@@ -4104,8 +4322,8 @@
         </p:nvSpPr>
         <p:spPr>
           <a:xfrm>
-            <a:off x="11091672" y="6318504"/>
-            <a:ext cx="548640" cy="329184"/>
+            <a:off x="548640" y="6400800"/>
+            <a:ext cx="365760" cy="292608"/>
           </a:xfrm>
           <a:prstGeom prst="rect">
             <a:avLst/>
@@ -4117,20 +4335,20 @@
           </a:extLst>
         </p:spPr>
         <p:txBody>
-          <a:bodyPr anchor="ctr"/>
+          <a:bodyPr lIns="0" tIns="0" rIns="0" bIns="0" anchor="ctr"/>
           <a:lstStyle>
             <a:lvl1pPr>
               <a:defRPr sz="1000">
                 <a:solidFill>
-                  <a:schemeClr val="accent6"/>
+                  <a:schemeClr val="bg1"/>
                 </a:solidFill>
               </a:defRPr>
             </a:lvl1pPr>
           </a:lstStyle>
           <a:p>
-            <a:pPr algn="r"/>
+            <a:pPr algn="l"/>
             <a:fld id="{F7021451-1387-4CA6-816F-3879F97B5CBC}" type="slidenum">
-              <a:rPr b="0" lang="en-US"/>
+              <a:rPr b="1" lang="en-US"/>
               <a:t>4</a:t>
             </a:fld>
             <a:endParaRPr lang="en-US"/>
@@ -4172,8 +4390,8 @@
         </p:nvSpPr>
         <p:spPr>
           <a:xfrm>
-            <a:off x="548640" y="411480"/>
-            <a:ext cx="11091672" cy="822960"/>
+            <a:off x="548640" y="182880"/>
+            <a:ext cx="7315200" cy="822960"/>
           </a:xfrm>
           <a:prstGeom prst="rect">
             <a:avLst/>
@@ -4191,7 +4409,7 @@
             <a:r>
               <a:rPr lang="en-US" sz="3600" b="1" dirty="0">
                 <a:solidFill>
-                  <a:schemeClr val="tx1"/>
+                  <a:schemeClr val="bg1"/>
                 </a:solidFill>
               </a:rPr>
               <a:t>Methods</a:t>
@@ -4208,8 +4426,8 @@
         </p:nvSpPr>
         <p:spPr>
           <a:xfrm>
-            <a:off x="548640" y="2057400"/>
-            <a:ext cx="1097280" cy="1097280"/>
+            <a:off x="548640" y="1691640"/>
+            <a:ext cx="1005840" cy="1005840"/>
           </a:xfrm>
           <a:prstGeom prst="ellipse">
             <a:avLst/>
@@ -4236,8 +4454,8 @@
         </p:blipFill>
         <p:spPr>
           <a:xfrm>
-            <a:off x="822960" y="2331720"/>
-            <a:ext cx="548640" cy="548640"/>
+            <a:off x="800100" y="1943100"/>
+            <a:ext cx="502920" cy="502920"/>
           </a:xfrm>
           <a:prstGeom prst="rect">
             <a:avLst/>
@@ -4260,7 +4478,7 @@
         </p:blipFill>
         <p:spPr>
           <a:xfrm>
-            <a:off x="2386584" y="2441448"/>
+            <a:off x="2340864" y="2029968"/>
             <a:ext cx="329184" cy="329184"/>
           </a:xfrm>
           <a:prstGeom prst="rect">
@@ -4276,8 +4494,8 @@
         </p:nvSpPr>
         <p:spPr>
           <a:xfrm>
-            <a:off x="548640" y="3429000"/>
-            <a:ext cx="2377440" cy="457200"/>
+            <a:off x="548640" y="2926080"/>
+            <a:ext cx="2377440" cy="411480"/>
           </a:xfrm>
           <a:prstGeom prst="rect">
             <a:avLst/>
@@ -4286,7 +4504,7 @@
           <a:ln/>
         </p:spPr>
         <p:txBody>
-          <a:bodyPr wrap="square" lIns="0" tIns="0" rIns="0" bIns="0" rtlCol="0" anchor="ctr"/>
+          <a:bodyPr wrap="square" lIns="0" tIns="0" rIns="0" bIns="0" rtlCol="0" anchor="t"/>
           <a:lstStyle/>
           <a:p>
             <a:pPr indent="0" marL="0">
@@ -4315,8 +4533,8 @@
         </p:nvSpPr>
         <p:spPr>
           <a:xfrm>
-            <a:off x="548640" y="3886200"/>
-            <a:ext cx="2377440" cy="320040"/>
+            <a:off x="548640" y="3383280"/>
+            <a:ext cx="2377440" cy="292608"/>
           </a:xfrm>
           <a:prstGeom prst="rect">
             <a:avLst/>
@@ -4325,7 +4543,7 @@
           <a:ln/>
         </p:spPr>
         <p:txBody>
-          <a:bodyPr wrap="square" lIns="0" tIns="0" rIns="0" bIns="0" rtlCol="0" anchor="ctr"/>
+          <a:bodyPr wrap="square" lIns="0" tIns="0" rIns="0" bIns="0" rtlCol="0" anchor="t"/>
           <a:lstStyle/>
           <a:p>
             <a:pPr indent="0" marL="0">
@@ -4334,7 +4552,7 @@
             <a:r>
               <a:rPr lang="en-US" sz="1400" b="1" dirty="0">
                 <a:solidFill>
-                  <a:schemeClr val="tx2"/>
+                  <a:schemeClr val="accent1"/>
                 </a:solidFill>
               </a:rPr>
               <a:t>Dylan Gonzales</a:t>
@@ -4351,8 +4569,8 @@
         </p:nvSpPr>
         <p:spPr>
           <a:xfrm>
-            <a:off x="548640" y="4343400"/>
-            <a:ext cx="2377440" cy="1463040"/>
+            <a:off x="548640" y="3794760"/>
+            <a:ext cx="2240280" cy="685800"/>
           </a:xfrm>
           <a:prstGeom prst="rect">
             <a:avLst/>
@@ -4387,8 +4605,8 @@
         </p:nvSpPr>
         <p:spPr>
           <a:xfrm>
-            <a:off x="3456432" y="2057400"/>
-            <a:ext cx="1097280" cy="1097280"/>
+            <a:off x="3456432" y="1691640"/>
+            <a:ext cx="1005840" cy="1005840"/>
           </a:xfrm>
           <a:prstGeom prst="ellipse">
             <a:avLst/>
@@ -4415,8 +4633,8 @@
         </p:blipFill>
         <p:spPr>
           <a:xfrm>
-            <a:off x="3730752" y="2331720"/>
-            <a:ext cx="548640" cy="548640"/>
+            <a:off x="3707892" y="1943100"/>
+            <a:ext cx="502920" cy="502920"/>
           </a:xfrm>
           <a:prstGeom prst="rect">
             <a:avLst/>
@@ -4439,7 +4657,7 @@
         </p:blipFill>
         <p:spPr>
           <a:xfrm>
-            <a:off x="5294376" y="2441448"/>
+            <a:off x="5248656" y="2029968"/>
             <a:ext cx="329184" cy="329184"/>
           </a:xfrm>
           <a:prstGeom prst="rect">
@@ -4455,8 +4673,8 @@
         </p:nvSpPr>
         <p:spPr>
           <a:xfrm>
-            <a:off x="3456432" y="3429000"/>
-            <a:ext cx="2377440" cy="457200"/>
+            <a:off x="3456432" y="2926080"/>
+            <a:ext cx="2377440" cy="411480"/>
           </a:xfrm>
           <a:prstGeom prst="rect">
             <a:avLst/>
@@ -4465,7 +4683,7 @@
           <a:ln/>
         </p:spPr>
         <p:txBody>
-          <a:bodyPr wrap="square" lIns="0" tIns="0" rIns="0" bIns="0" rtlCol="0" anchor="ctr"/>
+          <a:bodyPr wrap="square" lIns="0" tIns="0" rIns="0" bIns="0" rtlCol="0" anchor="t"/>
           <a:lstStyle/>
           <a:p>
             <a:pPr indent="0" marL="0">
@@ -4494,8 +4712,8 @@
         </p:nvSpPr>
         <p:spPr>
           <a:xfrm>
-            <a:off x="3456432" y="3886200"/>
-            <a:ext cx="2377440" cy="320040"/>
+            <a:off x="3456432" y="3383280"/>
+            <a:ext cx="2377440" cy="292608"/>
           </a:xfrm>
           <a:prstGeom prst="rect">
             <a:avLst/>
@@ -4504,7 +4722,7 @@
           <a:ln/>
         </p:spPr>
         <p:txBody>
-          <a:bodyPr wrap="square" lIns="0" tIns="0" rIns="0" bIns="0" rtlCol="0" anchor="ctr"/>
+          <a:bodyPr wrap="square" lIns="0" tIns="0" rIns="0" bIns="0" rtlCol="0" anchor="t"/>
           <a:lstStyle/>
           <a:p>
             <a:pPr indent="0" marL="0">
@@ -4513,7 +4731,7 @@
             <a:r>
               <a:rPr lang="en-US" sz="1400" b="1" dirty="0">
                 <a:solidFill>
-                  <a:schemeClr val="tx2"/>
+                  <a:schemeClr val="accent1"/>
                 </a:solidFill>
               </a:rPr>
               <a:t>James Wanueka</a:t>
@@ -4530,8 +4748,8 @@
         </p:nvSpPr>
         <p:spPr>
           <a:xfrm>
-            <a:off x="3456432" y="4343400"/>
-            <a:ext cx="2377440" cy="1463040"/>
+            <a:off x="3456432" y="3794760"/>
+            <a:ext cx="2240280" cy="685800"/>
           </a:xfrm>
           <a:prstGeom prst="rect">
             <a:avLst/>
@@ -4566,8 +4784,8 @@
         </p:nvSpPr>
         <p:spPr>
           <a:xfrm>
-            <a:off x="6364224" y="2057400"/>
-            <a:ext cx="1097280" cy="1097280"/>
+            <a:off x="6364224" y="1691640"/>
+            <a:ext cx="1005840" cy="1005840"/>
           </a:xfrm>
           <a:prstGeom prst="ellipse">
             <a:avLst/>
@@ -4594,8 +4812,8 @@
         </p:blipFill>
         <p:spPr>
           <a:xfrm>
-            <a:off x="6638544" y="2331720"/>
-            <a:ext cx="548640" cy="548640"/>
+            <a:off x="6615684" y="1943100"/>
+            <a:ext cx="502920" cy="502920"/>
           </a:xfrm>
           <a:prstGeom prst="rect">
             <a:avLst/>
@@ -4618,7 +4836,7 @@
         </p:blipFill>
         <p:spPr>
           <a:xfrm>
-            <a:off x="8202168" y="2441448"/>
+            <a:off x="8156448" y="2029968"/>
             <a:ext cx="329184" cy="329184"/>
           </a:xfrm>
           <a:prstGeom prst="rect">
@@ -4634,8 +4852,8 @@
         </p:nvSpPr>
         <p:spPr>
           <a:xfrm>
-            <a:off x="6364224" y="3429000"/>
-            <a:ext cx="2377440" cy="457200"/>
+            <a:off x="6364224" y="2926080"/>
+            <a:ext cx="2377440" cy="411480"/>
           </a:xfrm>
           <a:prstGeom prst="rect">
             <a:avLst/>
@@ -4644,7 +4862,7 @@
           <a:ln/>
         </p:spPr>
         <p:txBody>
-          <a:bodyPr wrap="square" lIns="0" tIns="0" rIns="0" bIns="0" rtlCol="0" anchor="ctr"/>
+          <a:bodyPr wrap="square" lIns="0" tIns="0" rIns="0" bIns="0" rtlCol="0" anchor="t"/>
           <a:lstStyle/>
           <a:p>
             <a:pPr indent="0" marL="0">
@@ -4673,8 +4891,8 @@
         </p:nvSpPr>
         <p:spPr>
           <a:xfrm>
-            <a:off x="6364224" y="3886200"/>
-            <a:ext cx="2377440" cy="320040"/>
+            <a:off x="6364224" y="3383280"/>
+            <a:ext cx="2377440" cy="292608"/>
           </a:xfrm>
           <a:prstGeom prst="rect">
             <a:avLst/>
@@ -4683,7 +4901,7 @@
           <a:ln/>
         </p:spPr>
         <p:txBody>
-          <a:bodyPr wrap="square" lIns="0" tIns="0" rIns="0" bIns="0" rtlCol="0" anchor="ctr"/>
+          <a:bodyPr wrap="square" lIns="0" tIns="0" rIns="0" bIns="0" rtlCol="0" anchor="t"/>
           <a:lstStyle/>
           <a:p>
             <a:pPr indent="0" marL="0">
@@ -4692,7 +4910,7 @@
             <a:r>
               <a:rPr lang="en-US" sz="1400" b="1" dirty="0">
                 <a:solidFill>
-                  <a:schemeClr val="tx2"/>
+                  <a:schemeClr val="accent1"/>
                 </a:solidFill>
               </a:rPr>
               <a:t>Micah Watkins</a:t>
@@ -4709,8 +4927,8 @@
         </p:nvSpPr>
         <p:spPr>
           <a:xfrm>
-            <a:off x="6364224" y="4343400"/>
-            <a:ext cx="2377440" cy="1463040"/>
+            <a:off x="6364224" y="3794760"/>
+            <a:ext cx="2240280" cy="685800"/>
           </a:xfrm>
           <a:prstGeom prst="rect">
             <a:avLst/>
@@ -4745,8 +4963,8 @@
         </p:nvSpPr>
         <p:spPr>
           <a:xfrm>
-            <a:off x="9272016" y="2057400"/>
-            <a:ext cx="1097280" cy="1097280"/>
+            <a:off x="9272016" y="1691640"/>
+            <a:ext cx="1005840" cy="1005840"/>
           </a:xfrm>
           <a:prstGeom prst="ellipse">
             <a:avLst/>
@@ -4773,8 +4991,8 @@
         </p:blipFill>
         <p:spPr>
           <a:xfrm>
-            <a:off x="9546336" y="2331720"/>
-            <a:ext cx="548640" cy="548640"/>
+            <a:off x="9523476" y="1943100"/>
+            <a:ext cx="502920" cy="502920"/>
           </a:xfrm>
           <a:prstGeom prst="rect">
             <a:avLst/>
@@ -4789,8 +5007,8 @@
         </p:nvSpPr>
         <p:spPr>
           <a:xfrm>
-            <a:off x="9272016" y="3429000"/>
-            <a:ext cx="2377440" cy="457200"/>
+            <a:off x="9272016" y="2926080"/>
+            <a:ext cx="2377440" cy="411480"/>
           </a:xfrm>
           <a:prstGeom prst="rect">
             <a:avLst/>
@@ -4799,7 +5017,7 @@
           <a:ln/>
         </p:spPr>
         <p:txBody>
-          <a:bodyPr wrap="square" lIns="0" tIns="0" rIns="0" bIns="0" rtlCol="0" anchor="ctr"/>
+          <a:bodyPr wrap="square" lIns="0" tIns="0" rIns="0" bIns="0" rtlCol="0" anchor="t"/>
           <a:lstStyle/>
           <a:p>
             <a:pPr indent="0" marL="0">
@@ -4828,8 +5046,8 @@
         </p:nvSpPr>
         <p:spPr>
           <a:xfrm>
-            <a:off x="9272016" y="3886200"/>
-            <a:ext cx="2377440" cy="320040"/>
+            <a:off x="9272016" y="3383280"/>
+            <a:ext cx="2377440" cy="292608"/>
           </a:xfrm>
           <a:prstGeom prst="rect">
             <a:avLst/>
@@ -4838,7 +5056,7 @@
           <a:ln/>
         </p:spPr>
         <p:txBody>
-          <a:bodyPr wrap="square" lIns="0" tIns="0" rIns="0" bIns="0" rtlCol="0" anchor="ctr"/>
+          <a:bodyPr wrap="square" lIns="0" tIns="0" rIns="0" bIns="0" rtlCol="0" anchor="t"/>
           <a:lstStyle/>
           <a:p>
             <a:pPr indent="0" marL="0">
@@ -4847,7 +5065,7 @@
             <a:r>
               <a:rPr lang="en-US" sz="1400" b="1" dirty="0">
                 <a:solidFill>
-                  <a:schemeClr val="tx2"/>
+                  <a:schemeClr val="accent1"/>
                 </a:solidFill>
               </a:rPr>
               <a:t>Meckrem Yousef</a:t>
@@ -4864,8 +5082,8 @@
         </p:nvSpPr>
         <p:spPr>
           <a:xfrm>
-            <a:off x="9272016" y="4343400"/>
-            <a:ext cx="2377440" cy="1463040"/>
+            <a:off x="9272016" y="3794760"/>
+            <a:ext cx="2240280" cy="685800"/>
           </a:xfrm>
           <a:prstGeom prst="rect">
             <a:avLst/>
@@ -4887,6 +5105,53 @@
                 </a:solidFill>
               </a:rPr>
               <a:t>One or two lines on what this step did</a:t>
+            </a:r>
+            <a:endParaRPr lang="en-US" sz="1600" dirty="0"/>
+          </a:p>
+        </p:txBody>
+      </p:sp>
+      <p:sp>
+        <p:nvSpPr>
+          <p:cNvPr id="26" name="Text 17"/>
+          <p:cNvSpPr txBox="1"/>
+          <p:nvPr/>
+        </p:nvSpPr>
+        <p:spPr>
+          <a:xfrm>
+            <a:off x="548640" y="4983480"/>
+            <a:ext cx="8961120" cy="365760"/>
+          </a:xfrm>
+          <a:prstGeom prst="rect">
+            <a:avLst/>
+          </a:prstGeom>
+          <a:noFill/>
+          <a:ln/>
+        </p:spPr>
+        <p:txBody>
+          <a:bodyPr wrap="square" lIns="0" tIns="0" rIns="0" bIns="0" rtlCol="0" anchor="ctr"/>
+          <a:lstStyle/>
+          <a:p>
+            <a:pPr indent="0" marL="0">
+              <a:buNone/>
+            </a:pPr>
+            <a:r>
+              <a:rPr lang="en-US" sz="1600" b="1" dirty="0">
+                <a:solidFill>
+                  <a:schemeClr val="tx1"/>
+                </a:solidFill>
+              </a:rPr>
+              <a:t>Tools  </a:t>
+            </a:r>
+            <a:pPr indent="0" marL="0">
+              <a:buNone/>
+            </a:pPr>
+            <a:r>
+              <a:rPr lang="en-US" sz="1600" dirty="0">
+                <a:solidFill>
+                  <a:schemeClr val="tx2"/>
+                </a:solidFill>
+              </a:rPr>
+              <a:t>Python  ·  pandas  ·  Plotly  ·  Streamlit  ·  GitHub</a:t>
             </a:r>
             <a:endParaRPr lang="en-US" sz="1600" dirty="0"/>
           </a:p>
@@ -4904,8 +5169,8 @@
         </p:nvSpPr>
         <p:spPr>
           <a:xfrm>
-            <a:off x="11091672" y="6318504"/>
-            <a:ext cx="548640" cy="329184"/>
+            <a:off x="548640" y="6400800"/>
+            <a:ext cx="365760" cy="292608"/>
           </a:xfrm>
           <a:prstGeom prst="rect">
             <a:avLst/>
@@ -4917,20 +5182,20 @@
           </a:extLst>
         </p:spPr>
         <p:txBody>
-          <a:bodyPr anchor="ctr"/>
+          <a:bodyPr lIns="0" tIns="0" rIns="0" bIns="0" anchor="ctr"/>
           <a:lstStyle>
             <a:lvl1pPr>
               <a:defRPr sz="1000">
                 <a:solidFill>
-                  <a:schemeClr val="accent6"/>
+                  <a:schemeClr val="bg1"/>
                 </a:solidFill>
               </a:defRPr>
             </a:lvl1pPr>
           </a:lstStyle>
           <a:p>
-            <a:pPr algn="r"/>
+            <a:pPr algn="l"/>
             <a:fld id="{F7021451-1387-4CA6-816F-3879F97B5CBC}" type="slidenum">
-              <a:rPr b="0" lang="en-US"/>
+              <a:rPr b="1" lang="en-US"/>
               <a:t>5</a:t>
             </a:fld>
             <a:endParaRPr lang="en-US"/>
@@ -4972,8 +5237,8 @@
         </p:nvSpPr>
         <p:spPr>
           <a:xfrm>
-            <a:off x="548640" y="411480"/>
-            <a:ext cx="11091672" cy="822960"/>
+            <a:off x="548640" y="182880"/>
+            <a:ext cx="7315200" cy="822960"/>
           </a:xfrm>
           <a:prstGeom prst="rect">
             <a:avLst/>
@@ -4991,7 +5256,7 @@
             <a:r>
               <a:rPr lang="en-US" sz="3600" b="1" dirty="0">
                 <a:solidFill>
-                  <a:schemeClr val="tx1"/>
+                  <a:schemeClr val="bg1"/>
                 </a:solidFill>
               </a:rPr>
               <a:t>Results</a:t>
@@ -5009,11 +5274,11 @@
         <p:spPr>
           <a:xfrm>
             <a:off x="548640" y="1508760"/>
-            <a:ext cx="7315200" cy="4434840"/>
+            <a:ext cx="7269480" cy="3977640"/>
           </a:xfrm>
           <a:prstGeom prst="roundRect">
             <a:avLst>
-              <a:gd name="adj" fmla="val 2474"/>
+              <a:gd name="adj" fmla="val 2759"/>
             </a:avLst>
           </a:prstGeom>
           <a:solidFill>
@@ -5035,8 +5300,8 @@
         </p:nvSpPr>
         <p:spPr>
           <a:xfrm>
-            <a:off x="3794760" y="2857500"/>
-            <a:ext cx="822960" cy="822960"/>
+            <a:off x="3817620" y="2674620"/>
+            <a:ext cx="731520" cy="731520"/>
           </a:xfrm>
           <a:prstGeom prst="ellipse">
             <a:avLst/>
@@ -5063,8 +5328,8 @@
         </p:blipFill>
         <p:spPr>
           <a:xfrm>
-            <a:off x="4000500" y="3063240"/>
-            <a:ext cx="411480" cy="411480"/>
+            <a:off x="4000500" y="2857500"/>
+            <a:ext cx="365760" cy="365760"/>
           </a:xfrm>
           <a:prstGeom prst="rect">
             <a:avLst/>
@@ -5079,8 +5344,8 @@
         </p:nvSpPr>
         <p:spPr>
           <a:xfrm>
-            <a:off x="914400" y="3817620"/>
-            <a:ext cx="6583680" cy="868680"/>
+            <a:off x="914400" y="3543300"/>
+            <a:ext cx="6537960" cy="777240"/>
           </a:xfrm>
           <a:prstGeom prst="rect">
             <a:avLst/>
@@ -5129,14 +5394,50 @@
       </p:sp>
       <p:sp>
         <p:nvSpPr>
-          <p:cNvPr id="7" name="Key number"/>
+          <p:cNvPr id="7" name="Caption"/>
           <p:cNvSpPr txBox="1"/>
           <p:nvPr/>
         </p:nvSpPr>
         <p:spPr>
           <a:xfrm>
-            <a:off x="8229600" y="1508760"/>
-            <a:ext cx="3410712" cy="914400"/>
+            <a:off x="548640" y="5577840"/>
+            <a:ext cx="7269480" cy="320040"/>
+          </a:xfrm>
+          <a:prstGeom prst="rect">
+            <a:avLst/>
+          </a:prstGeom>
+          <a:noFill/>
+          <a:ln/>
+        </p:spPr>
+        <p:txBody>
+          <a:bodyPr wrap="square" lIns="0" tIns="0" rIns="0" bIns="0" rtlCol="0" anchor="t"/>
+          <a:lstStyle/>
+          <a:p>
+            <a:pPr indent="0" marL="0">
+              <a:buNone/>
+            </a:pPr>
+            <a:r>
+              <a:rPr lang="en-US" sz="1200" i="1" dirty="0">
+                <a:solidFill>
+                  <a:schemeClr val="accent6"/>
+                </a:solidFill>
+              </a:rPr>
+              <a:t>Figure caption and source</a:t>
+            </a:r>
+            <a:endParaRPr lang="en-US" sz="1200" dirty="0"/>
+          </a:p>
+        </p:txBody>
+      </p:sp>
+      <p:sp>
+        <p:nvSpPr>
+          <p:cNvPr id="8" name="Key number"/>
+          <p:cNvSpPr txBox="1"/>
+          <p:nvPr/>
+        </p:nvSpPr>
+        <p:spPr>
+          <a:xfrm>
+            <a:off x="8183880" y="1508760"/>
+            <a:ext cx="3456432" cy="868680"/>
           </a:xfrm>
           <a:prstGeom prst="rect">
             <a:avLst/>
@@ -5168,50 +5469,50 @@
       </p:sp>
       <p:sp>
         <p:nvSpPr>
-          <p:cNvPr id="8" name="Text 5"/>
-          <p:cNvSpPr txBox="1"/>
-          <p:nvPr/>
-        </p:nvSpPr>
-        <p:spPr>
-          <a:xfrm>
-            <a:off x="8229600" y="2468880"/>
-            <a:ext cx="3410712" cy="640080"/>
-          </a:xfrm>
-          <a:prstGeom prst="rect">
-            <a:avLst/>
-          </a:prstGeom>
-          <a:noFill/>
-          <a:ln/>
-        </p:spPr>
-        <p:txBody>
-          <a:bodyPr wrap="square" lIns="0" tIns="0" rIns="0" bIns="0" rtlCol="0" anchor="t"/>
-          <a:lstStyle/>
-          <a:p>
-            <a:pPr indent="0" marL="0">
-              <a:buNone/>
-            </a:pPr>
-            <a:r>
-              <a:rPr lang="en-US" sz="1400" dirty="0">
-                <a:solidFill>
-                  <a:schemeClr val="accent6"/>
-                </a:solidFill>
-              </a:rPr>
-              <a:t>Key number and what it measures</a:t>
-            </a:r>
-            <a:endParaRPr lang="en-US" sz="1400" dirty="0"/>
-          </a:p>
-        </p:txBody>
-      </p:sp>
-      <p:sp>
-        <p:nvSpPr>
           <p:cNvPr id="9" name="Text 6"/>
           <p:cNvSpPr txBox="1"/>
           <p:nvPr/>
         </p:nvSpPr>
         <p:spPr>
           <a:xfrm>
-            <a:off x="8229600" y="3337560"/>
-            <a:ext cx="3410712" cy="2606040"/>
+            <a:off x="8183880" y="2423160"/>
+            <a:ext cx="3456432" cy="365760"/>
+          </a:xfrm>
+          <a:prstGeom prst="rect">
+            <a:avLst/>
+          </a:prstGeom>
+          <a:noFill/>
+          <a:ln/>
+        </p:spPr>
+        <p:txBody>
+          <a:bodyPr wrap="square" lIns="0" tIns="0" rIns="0" bIns="0" rtlCol="0" anchor="t"/>
+          <a:lstStyle/>
+          <a:p>
+            <a:pPr indent="0" marL="0">
+              <a:buNone/>
+            </a:pPr>
+            <a:r>
+              <a:rPr lang="en-US" sz="1400" dirty="0">
+                <a:solidFill>
+                  <a:schemeClr val="accent6"/>
+                </a:solidFill>
+              </a:rPr>
+              <a:t>Key number and what it measures</a:t>
+            </a:r>
+            <a:endParaRPr lang="en-US" sz="1400" dirty="0"/>
+          </a:p>
+        </p:txBody>
+      </p:sp>
+      <p:sp>
+        <p:nvSpPr>
+          <p:cNvPr id="10" name="Text 7"/>
+          <p:cNvSpPr txBox="1"/>
+          <p:nvPr/>
+        </p:nvSpPr>
+        <p:spPr>
+          <a:xfrm>
+            <a:off x="8183880" y="3017520"/>
+            <a:ext cx="3456432" cy="1371600"/>
           </a:xfrm>
           <a:prstGeom prst="rect">
             <a:avLst/>
@@ -5270,8 +5571,8 @@
         </p:nvSpPr>
         <p:spPr>
           <a:xfrm>
-            <a:off x="11091672" y="6318504"/>
-            <a:ext cx="548640" cy="329184"/>
+            <a:off x="548640" y="6400800"/>
+            <a:ext cx="365760" cy="292608"/>
           </a:xfrm>
           <a:prstGeom prst="rect">
             <a:avLst/>
@@ -5283,20 +5584,20 @@
           </a:extLst>
         </p:spPr>
         <p:txBody>
-          <a:bodyPr anchor="ctr"/>
+          <a:bodyPr lIns="0" tIns="0" rIns="0" bIns="0" anchor="ctr"/>
           <a:lstStyle>
             <a:lvl1pPr>
               <a:defRPr sz="1000">
                 <a:solidFill>
-                  <a:schemeClr val="accent6"/>
+                  <a:schemeClr val="bg1"/>
                 </a:solidFill>
               </a:defRPr>
             </a:lvl1pPr>
           </a:lstStyle>
           <a:p>
-            <a:pPr algn="r"/>
+            <a:pPr algn="l"/>
             <a:fld id="{F7021451-1387-4CA6-816F-3879F97B5CBC}" type="slidenum">
-              <a:rPr b="0" lang="en-US"/>
+              <a:rPr b="1" lang="en-US"/>
               <a:t>6</a:t>
             </a:fld>
             <a:endParaRPr lang="en-US"/>
@@ -5338,8 +5639,8 @@
         </p:nvSpPr>
         <p:spPr>
           <a:xfrm>
-            <a:off x="548640" y="411480"/>
-            <a:ext cx="11091672" cy="822960"/>
+            <a:off x="548640" y="182880"/>
+            <a:ext cx="7315200" cy="822960"/>
           </a:xfrm>
           <a:prstGeom prst="rect">
             <a:avLst/>
@@ -5357,7 +5658,7 @@
             <a:r>
               <a:rPr lang="en-US" sz="3600" b="1" dirty="0">
                 <a:solidFill>
-                  <a:schemeClr val="tx1"/>
+                  <a:schemeClr val="bg1"/>
                 </a:solidFill>
               </a:rPr>
               <a:t>Findings</a:t>
@@ -5374,12 +5675,12 @@
         </p:nvSpPr>
         <p:spPr>
           <a:xfrm>
-            <a:off x="548640" y="1600200"/>
-            <a:ext cx="3529584" cy="4206240"/>
+            <a:off x="548640" y="1508760"/>
+            <a:ext cx="3529584" cy="2697480"/>
           </a:xfrm>
           <a:prstGeom prst="roundRect">
             <a:avLst>
-              <a:gd name="adj" fmla="val 3109"/>
+              <a:gd name="adj" fmla="val 4068"/>
             </a:avLst>
           </a:prstGeom>
           <a:solidFill>
@@ -5396,8 +5697,8 @@
         </p:nvSpPr>
         <p:spPr>
           <a:xfrm>
-            <a:off x="868680" y="1965960"/>
-            <a:ext cx="731520" cy="731520"/>
+            <a:off x="822960" y="1783080"/>
+            <a:ext cx="685800" cy="685800"/>
           </a:xfrm>
           <a:prstGeom prst="ellipse">
             <a:avLst/>
@@ -5424,8 +5725,8 @@
         </p:blipFill>
         <p:spPr>
           <a:xfrm>
-            <a:off x="1051560" y="2148840"/>
-            <a:ext cx="365760" cy="365760"/>
+            <a:off x="994410" y="1954530"/>
+            <a:ext cx="342900" cy="342900"/>
           </a:xfrm>
           <a:prstGeom prst="rect">
             <a:avLst/>
@@ -5440,8 +5741,8 @@
         </p:nvSpPr>
         <p:spPr>
           <a:xfrm>
-            <a:off x="868680" y="2926080"/>
-            <a:ext cx="2889504" cy="731520"/>
+            <a:off x="822960" y="2651760"/>
+            <a:ext cx="2980944" cy="411480"/>
           </a:xfrm>
           <a:prstGeom prst="rect">
             <a:avLst/>
@@ -5457,7 +5758,7 @@
               <a:buNone/>
             </a:pPr>
             <a:r>
-              <a:rPr lang="en-US" sz="2200" b="1" dirty="0">
+              <a:rPr lang="en-US" sz="2000" b="1" dirty="0">
                 <a:solidFill>
                   <a:schemeClr val="tx1"/>
                 </a:solidFill>
@@ -5467,7 +5768,7 @@
               </a:rPr>
               <a:t>What the data show</a:t>
             </a:r>
-            <a:endParaRPr lang="en-US" sz="2200" dirty="0"/>
+            <a:endParaRPr lang="en-US" sz="2000" dirty="0"/>
           </a:p>
         </p:txBody>
       </p:sp>
@@ -5479,8 +5780,8 @@
         </p:nvSpPr>
         <p:spPr>
           <a:xfrm>
-            <a:off x="868680" y="3703320"/>
-            <a:ext cx="2889504" cy="1737360"/>
+            <a:off x="822960" y="3154680"/>
+            <a:ext cx="2980944" cy="868680"/>
           </a:xfrm>
           <a:prstGeom prst="rect">
             <a:avLst/>
@@ -5493,9 +5794,6 @@
           <a:lstStyle/>
           <a:p>
             <a:pPr marL="342900" indent="-342900">
-              <a:spcAft>
-                <a:spcPts val="800"/>
-              </a:spcAft>
               <a:buSzPct val="100000"/>
               <a:buChar char="•"/>
             </a:pPr>
@@ -5519,12 +5817,12 @@
         </p:nvSpPr>
         <p:spPr>
           <a:xfrm>
-            <a:off x="4334256" y="1600200"/>
-            <a:ext cx="3529584" cy="4206240"/>
+            <a:off x="4334256" y="1508760"/>
+            <a:ext cx="3529584" cy="2697480"/>
           </a:xfrm>
           <a:prstGeom prst="roundRect">
             <a:avLst>
-              <a:gd name="adj" fmla="val 3109"/>
+              <a:gd name="adj" fmla="val 4068"/>
             </a:avLst>
           </a:prstGeom>
           <a:solidFill>
@@ -5541,8 +5839,8 @@
         </p:nvSpPr>
         <p:spPr>
           <a:xfrm>
-            <a:off x="4654296" y="1965960"/>
-            <a:ext cx="731520" cy="731520"/>
+            <a:off x="4608576" y="1783080"/>
+            <a:ext cx="685800" cy="685800"/>
           </a:xfrm>
           <a:prstGeom prst="ellipse">
             <a:avLst/>
@@ -5569,8 +5867,8 @@
         </p:blipFill>
         <p:spPr>
           <a:xfrm>
-            <a:off x="4837176" y="2148840"/>
-            <a:ext cx="365760" cy="365760"/>
+            <a:off x="4780026" y="1954530"/>
+            <a:ext cx="342900" cy="342900"/>
           </a:xfrm>
           <a:prstGeom prst="rect">
             <a:avLst/>
@@ -5585,8 +5883,8 @@
         </p:nvSpPr>
         <p:spPr>
           <a:xfrm>
-            <a:off x="4654296" y="2926080"/>
-            <a:ext cx="2889504" cy="731520"/>
+            <a:off x="4608576" y="2651760"/>
+            <a:ext cx="2980944" cy="411480"/>
           </a:xfrm>
           <a:prstGeom prst="rect">
             <a:avLst/>
@@ -5602,7 +5900,7 @@
               <a:buNone/>
             </a:pPr>
             <a:r>
-              <a:rPr lang="en-US" sz="2200" b="1" dirty="0">
+              <a:rPr lang="en-US" sz="2000" b="1" dirty="0">
                 <a:solidFill>
                   <a:schemeClr val="tx1"/>
                 </a:solidFill>
@@ -5612,7 +5910,7 @@
               </a:rPr>
               <a:t>What they suggest</a:t>
             </a:r>
-            <a:endParaRPr lang="en-US" sz="2200" dirty="0"/>
+            <a:endParaRPr lang="en-US" sz="2000" dirty="0"/>
           </a:p>
         </p:txBody>
       </p:sp>
@@ -5624,8 +5922,8 @@
         </p:nvSpPr>
         <p:spPr>
           <a:xfrm>
-            <a:off x="4654296" y="3703320"/>
-            <a:ext cx="2889504" cy="1737360"/>
+            <a:off x="4608576" y="3154680"/>
+            <a:ext cx="2980944" cy="868680"/>
           </a:xfrm>
           <a:prstGeom prst="rect">
             <a:avLst/>
@@ -5638,9 +5936,6 @@
           <a:lstStyle/>
           <a:p>
             <a:pPr marL="342900" indent="-342900">
-              <a:spcAft>
-                <a:spcPts val="800"/>
-              </a:spcAft>
               <a:buSzPct val="100000"/>
               <a:buChar char="•"/>
             </a:pPr>
@@ -5664,12 +5959,12 @@
         </p:nvSpPr>
         <p:spPr>
           <a:xfrm>
-            <a:off x="8119872" y="1600200"/>
-            <a:ext cx="3529584" cy="4206240"/>
+            <a:off x="8119872" y="1508760"/>
+            <a:ext cx="3529584" cy="2697480"/>
           </a:xfrm>
           <a:prstGeom prst="roundRect">
             <a:avLst>
-              <a:gd name="adj" fmla="val 3109"/>
+              <a:gd name="adj" fmla="val 4068"/>
             </a:avLst>
           </a:prstGeom>
           <a:solidFill>
@@ -5686,8 +5981,8 @@
         </p:nvSpPr>
         <p:spPr>
           <a:xfrm>
-            <a:off x="8439912" y="1965960"/>
-            <a:ext cx="731520" cy="731520"/>
+            <a:off x="8394192" y="1783080"/>
+            <a:ext cx="685800" cy="685800"/>
           </a:xfrm>
           <a:prstGeom prst="ellipse">
             <a:avLst/>
@@ -5714,8 +6009,8 @@
         </p:blipFill>
         <p:spPr>
           <a:xfrm>
-            <a:off x="8622792" y="2148840"/>
-            <a:ext cx="365760" cy="365760"/>
+            <a:off x="8565642" y="1954530"/>
+            <a:ext cx="342900" cy="342900"/>
           </a:xfrm>
           <a:prstGeom prst="rect">
             <a:avLst/>
@@ -5730,8 +6025,8 @@
         </p:nvSpPr>
         <p:spPr>
           <a:xfrm>
-            <a:off x="8439912" y="2926080"/>
-            <a:ext cx="2889504" cy="731520"/>
+            <a:off x="8394192" y="2651760"/>
+            <a:ext cx="2980944" cy="411480"/>
           </a:xfrm>
           <a:prstGeom prst="rect">
             <a:avLst/>
@@ -5747,7 +6042,7 @@
               <a:buNone/>
             </a:pPr>
             <a:r>
-              <a:rPr lang="en-US" sz="2200" b="1" dirty="0">
+              <a:rPr lang="en-US" sz="2000" b="1" dirty="0">
                 <a:solidFill>
                   <a:schemeClr val="tx1"/>
                 </a:solidFill>
@@ -5757,7 +6052,7 @@
               </a:rPr>
               <a:t>Too limited to tell</a:t>
             </a:r>
-            <a:endParaRPr lang="en-US" sz="2200" dirty="0"/>
+            <a:endParaRPr lang="en-US" sz="2000" dirty="0"/>
           </a:p>
         </p:txBody>
       </p:sp>
@@ -5769,8 +6064,8 @@
         </p:nvSpPr>
         <p:spPr>
           <a:xfrm>
-            <a:off x="8439912" y="3703320"/>
-            <a:ext cx="2889504" cy="1737360"/>
+            <a:off x="8394192" y="3154680"/>
+            <a:ext cx="2980944" cy="868680"/>
           </a:xfrm>
           <a:prstGeom prst="rect">
             <a:avLst/>
@@ -5783,9 +6078,6 @@
           <a:lstStyle/>
           <a:p>
             <a:pPr marL="342900" indent="-342900">
-              <a:spcAft>
-                <a:spcPts val="800"/>
-              </a:spcAft>
               <a:buSzPct val="100000"/>
               <a:buChar char="•"/>
             </a:pPr>
@@ -5798,6 +6090,81 @@
               <a:t>Questions the data can't answer yet</a:t>
             </a:r>
             <a:endParaRPr lang="en-US" sz="1600" dirty="0"/>
+          </a:p>
+        </p:txBody>
+      </p:sp>
+      <p:sp>
+        <p:nvSpPr>
+          <p:cNvPr id="18" name="Bottom line card"/>
+          <p:cNvSpPr/>
+          <p:nvPr/>
+        </p:nvSpPr>
+        <p:spPr>
+          <a:xfrm>
+            <a:off x="548640" y="4480560"/>
+            <a:ext cx="9006840" cy="1097280"/>
+          </a:xfrm>
+          <a:prstGeom prst="roundRect">
+            <a:avLst>
+              <a:gd name="adj" fmla="val 10000"/>
+            </a:avLst>
+          </a:prstGeom>
+          <a:solidFill>
+            <a:schemeClr val="accent1"/>
+          </a:solidFill>
+          <a:ln/>
+        </p:spPr>
+      </p:sp>
+      <p:sp>
+        <p:nvSpPr>
+          <p:cNvPr id="19" name="Text 14"/>
+          <p:cNvSpPr txBox="1"/>
+          <p:nvPr/>
+        </p:nvSpPr>
+        <p:spPr>
+          <a:xfrm>
+            <a:off x="822960" y="4553712"/>
+            <a:ext cx="8458200" cy="950976"/>
+          </a:xfrm>
+          <a:prstGeom prst="rect">
+            <a:avLst/>
+          </a:prstGeom>
+          <a:noFill/>
+          <a:ln/>
+        </p:spPr>
+        <p:txBody>
+          <a:bodyPr wrap="square" lIns="0" tIns="0" rIns="0" bIns="0" rtlCol="0" anchor="ctr"/>
+          <a:lstStyle/>
+          <a:p>
+            <a:pPr indent="0" marL="0">
+              <a:buNone/>
+            </a:pPr>
+            <a:r>
+              <a:rPr lang="en-US" sz="1800" b="1" dirty="0">
+                <a:solidFill>
+                  <a:schemeClr val="bg1"/>
+                </a:solidFill>
+                <a:latin typeface="Cambria" pitchFamily="34" charset="0"/>
+                <a:ea typeface="Cambria" pitchFamily="34" charset="-122"/>
+                <a:cs typeface="Cambria" pitchFamily="34" charset="-120"/>
+              </a:rPr>
+              <a:t>Bottom line</a:t>
+            </a:r>
+            <a:endParaRPr lang="en-US" sz="1800" dirty="0"/>
+          </a:p>
+          <a:p>
+            <a:pPr indent="0" marL="0">
+              <a:buNone/>
+            </a:pPr>
+            <a:r>
+              <a:rPr lang="en-US" sz="1600" dirty="0">
+                <a:solidFill>
+                  <a:schemeClr val="bg2"/>
+                </a:solidFill>
+              </a:rPr>
+              <a:t>One sentence that answers the main question</a:t>
+            </a:r>
+            <a:endParaRPr lang="en-US" sz="1800" dirty="0"/>
           </a:p>
         </p:txBody>
       </p:sp>
@@ -5813,8 +6180,8 @@
         </p:nvSpPr>
         <p:spPr>
           <a:xfrm>
-            <a:off x="11091672" y="6318504"/>
-            <a:ext cx="548640" cy="329184"/>
+            <a:off x="548640" y="6400800"/>
+            <a:ext cx="365760" cy="292608"/>
           </a:xfrm>
           <a:prstGeom prst="rect">
             <a:avLst/>
@@ -5826,20 +6193,20 @@
           </a:extLst>
         </p:spPr>
         <p:txBody>
-          <a:bodyPr anchor="ctr"/>
+          <a:bodyPr lIns="0" tIns="0" rIns="0" bIns="0" anchor="ctr"/>
           <a:lstStyle>
             <a:lvl1pPr>
               <a:defRPr sz="1000">
                 <a:solidFill>
-                  <a:schemeClr val="accent6"/>
+                  <a:schemeClr val="bg1"/>
                 </a:solidFill>
               </a:defRPr>
             </a:lvl1pPr>
           </a:lstStyle>
           <a:p>
-            <a:pPr algn="r"/>
+            <a:pPr algn="l"/>
             <a:fld id="{F7021451-1387-4CA6-816F-3879F97B5CBC}" type="slidenum">
-              <a:rPr b="0" lang="en-US"/>
+              <a:rPr b="1" lang="en-US"/>
               <a:t>7</a:t>
             </a:fld>
             <a:endParaRPr lang="en-US"/>
@@ -5881,8 +6248,8 @@
         </p:nvSpPr>
         <p:spPr>
           <a:xfrm>
-            <a:off x="548640" y="411480"/>
-            <a:ext cx="11091672" cy="822960"/>
+            <a:off x="548640" y="182880"/>
+            <a:ext cx="7315200" cy="822960"/>
           </a:xfrm>
           <a:prstGeom prst="rect">
             <a:avLst/>
@@ -5900,7 +6267,7 @@
             <a:r>
               <a:rPr lang="en-US" sz="3600" b="1" dirty="0">
                 <a:solidFill>
-                  <a:schemeClr val="tx1"/>
+                  <a:schemeClr val="bg1"/>
                 </a:solidFill>
               </a:rPr>
               <a:t>Limitations</a:t>
@@ -5920,7 +6287,7 @@
         <p:spPr>
           <a:xfrm>
             <a:off x="548640" y="1508760"/>
-            <a:ext cx="5394960" cy="4434840"/>
+            <a:ext cx="5120640" cy="4343400"/>
           </a:xfrm>
           <a:prstGeom prst="rect">
             <a:avLst/>
@@ -6013,12 +6380,12 @@
         </p:nvSpPr>
         <p:spPr>
           <a:xfrm>
-            <a:off x="6355080" y="1508760"/>
-            <a:ext cx="5285232" cy="4434840"/>
+            <a:off x="6035040" y="1508760"/>
+            <a:ext cx="5605272" cy="2697480"/>
           </a:xfrm>
           <a:prstGeom prst="roundRect">
             <a:avLst>
-              <a:gd name="adj" fmla="val 2474"/>
+              <a:gd name="adj" fmla="val 4068"/>
             </a:avLst>
           </a:prstGeom>
           <a:solidFill>
@@ -6040,8 +6407,8 @@
         </p:nvSpPr>
         <p:spPr>
           <a:xfrm>
-            <a:off x="8586216" y="2857500"/>
-            <a:ext cx="822960" cy="822960"/>
+            <a:off x="8471916" y="2034540"/>
+            <a:ext cx="731520" cy="731520"/>
           </a:xfrm>
           <a:prstGeom prst="ellipse">
             <a:avLst/>
@@ -6068,8 +6435,8 @@
         </p:blipFill>
         <p:spPr>
           <a:xfrm>
-            <a:off x="8791956" y="3063240"/>
-            <a:ext cx="411480" cy="411480"/>
+            <a:off x="8654796" y="2217420"/>
+            <a:ext cx="365760" cy="365760"/>
           </a:xfrm>
           <a:prstGeom prst="rect">
             <a:avLst/>
@@ -6084,8 +6451,8 @@
         </p:nvSpPr>
         <p:spPr>
           <a:xfrm>
-            <a:off x="6720840" y="3817620"/>
-            <a:ext cx="4553712" cy="868680"/>
+            <a:off x="6400800" y="2903220"/>
+            <a:ext cx="4873752" cy="777240"/>
           </a:xfrm>
           <a:prstGeom prst="rect">
             <a:avLst/>
@@ -6129,6 +6496,42 @@
               <a:t>Where monitoring is dense, sparse, or absent</a:t>
             </a:r>
             <a:endParaRPr lang="en-US" sz="1800" dirty="0"/>
+          </a:p>
+        </p:txBody>
+      </p:sp>
+      <p:sp>
+        <p:nvSpPr>
+          <p:cNvPr id="8" name="Caption"/>
+          <p:cNvSpPr txBox="1"/>
+          <p:nvPr/>
+        </p:nvSpPr>
+        <p:spPr>
+          <a:xfrm>
+            <a:off x="6035040" y="4343400"/>
+            <a:ext cx="3566160" cy="320040"/>
+          </a:xfrm>
+          <a:prstGeom prst="rect">
+            <a:avLst/>
+          </a:prstGeom>
+          <a:noFill/>
+          <a:ln/>
+        </p:spPr>
+        <p:txBody>
+          <a:bodyPr wrap="square" lIns="0" tIns="0" rIns="0" bIns="0" rtlCol="0" anchor="t"/>
+          <a:lstStyle/>
+          <a:p>
+            <a:pPr indent="0" marL="0">
+              <a:buNone/>
+            </a:pPr>
+            <a:r>
+              <a:rPr lang="en-US" sz="1200" i="1" dirty="0">
+                <a:solidFill>
+                  <a:schemeClr val="accent6"/>
+                </a:solidFill>
+              </a:rPr>
+              <a:t>Figure caption and source</a:t>
+            </a:r>
+            <a:endParaRPr lang="en-US" sz="1200" dirty="0"/>
           </a:p>
         </p:txBody>
       </p:sp>
@@ -6144,8 +6547,8 @@
         </p:nvSpPr>
         <p:spPr>
           <a:xfrm>
-            <a:off x="11091672" y="6318504"/>
-            <a:ext cx="548640" cy="329184"/>
+            <a:off x="548640" y="6400800"/>
+            <a:ext cx="365760" cy="292608"/>
           </a:xfrm>
           <a:prstGeom prst="rect">
             <a:avLst/>
@@ -6157,20 +6560,20 @@
           </a:extLst>
         </p:spPr>
         <p:txBody>
-          <a:bodyPr anchor="ctr"/>
+          <a:bodyPr lIns="0" tIns="0" rIns="0" bIns="0" anchor="ctr"/>
           <a:lstStyle>
             <a:lvl1pPr>
               <a:defRPr sz="1000">
                 <a:solidFill>
-                  <a:schemeClr val="accent6"/>
+                  <a:schemeClr val="bg1"/>
                 </a:solidFill>
               </a:defRPr>
             </a:lvl1pPr>
           </a:lstStyle>
           <a:p>
-            <a:pPr algn="r"/>
+            <a:pPr algn="l"/>
             <a:fld id="{F7021451-1387-4CA6-816F-3879F97B5CBC}" type="slidenum">
-              <a:rPr b="0" lang="en-US"/>
+              <a:rPr b="1" lang="en-US"/>
               <a:t>8</a:t>
             </a:fld>
             <a:endParaRPr lang="en-US"/>

</xml_diff>

<commit_message>
Deployed e0d5918 with MkDocs version: 1.6.1
</commit_message>
<xml_diff>
--- a/files/beneath_the_mesa_slides.pptx
+++ b/files/beneath_the_mesa_slides.pptx
@@ -120,20 +120,20 @@
   <p:extLst>
     <p:ext uri="{521415D9-36F7-43E2-AB2F-B90AF26B5E84}">
       <p14:sectionLst xmlns:p14="http://schemas.microsoft.com/office/powerpoint/2010/main">
-        <p14:section name="Introduction" id="{bc25e1b8-b8f5-3d64-0c55-9195b65bef45}">
+        <p14:section name="Introduction" id="{7e524bcd-a430-7b6f-7e64-4ab6c4d4767b}">
           <p14:sldIdLst>
             <p14:sldId id="256"/>
             <p14:sldId id="257"/>
             <p14:sldId id="258"/>
           </p14:sldIdLst>
         </p14:section>
-        <p14:section name="Data and methods" id="{957f342e-54b9-274a-dd52-1996d47596dc}">
+        <p14:section name="Data and methods" id="{e273b042-eefe-d60b-fcb9-992c8767682a}">
           <p14:sldIdLst>
             <p14:sldId id="259"/>
             <p14:sldId id="260"/>
           </p14:sldIdLst>
         </p14:section>
-        <p14:section name="Team contributions" id="{2ab2fcd0-9653-9039-7eec-16b040df8a21}">
+        <p14:section name="Team contributions" id="{b00f7809-fdab-f366-c5a5-d5a076978926}">
           <p14:sldIdLst>
             <p14:sldId id="261"/>
             <p14:sldId id="262"/>
@@ -142,14 +142,14 @@
             <p14:sldId id="265"/>
           </p14:sldIdLst>
         </p14:section>
-        <p14:section name="Results" id="{ed544e21-b374-4726-05e8-bcea12b124a9}">
+        <p14:section name="Results" id="{96d16202-9c8d-41e3-c897-dbe014abe0eb}">
           <p14:sldIdLst>
             <p14:sldId id="266"/>
             <p14:sldId id="267"/>
             <p14:sldId id="268"/>
           </p14:sldIdLst>
         </p14:section>
-        <p14:section name="Wrap-up" id="{0a323fce-bf49-0321-96c0-9bb6832dfaa6}">
+        <p14:section name="Wrap-up" id="{7ba428bf-b513-0117-b724-771fe1b62936}">
           <p14:sldIdLst>
             <p14:sldId id="269"/>
           </p14:sldIdLst>
@@ -1538,7 +1538,7 @@
           <a:p>
             <a:r>
               <a:rPr lang="en-US" dirty="0"/>
-              <a:t>About 30 seconds. James Wanueka records this slide. Cover what you did, how you did it, and one thing you learned. Put a screenshot in the dashed box: the cleaning script, or the data before and after.
+              <a:t>About 30 seconds. James Wauneka records this slide. Cover what you did, how you did it, and one thing you learned. Put a screenshot in the dashed box: the cleaning script, or the data before and after.
 The circle in the bottom-right corner is where the presenter's camera goes; keep charts and text out of that corner.</a:t>
             </a:r>
             <a:endParaRPr lang="en-US" dirty="0"/>
@@ -3030,7 +3030,7 @@
                   <a:schemeClr val="accent4"/>
                 </a:solidFill>
               </a:rPr>
-              <a:t>Petar Djordjevic (PM)  ·  Meckrem Yousef  ·  James Wanueka</a:t>
+              <a:t>Petar Djordjevic (PM)  ·  Meckrem Yousef  ·  James Wauneka</a:t>
             </a:r>
             <a:endParaRPr lang="en-US" sz="1600" dirty="0"/>
           </a:p>
@@ -7732,7 +7732,7 @@
                   <a:schemeClr val="accent1"/>
                 </a:solidFill>
               </a:rPr>
-              <a:t>James Wanueka</a:t>
+              <a:t>James Wauneka</a:t>
             </a:r>
             <a:endParaRPr lang="en-US" sz="1400" dirty="0"/>
           </a:p>
@@ -9050,7 +9050,7 @@
       </p:sp>
       <p:sp>
         <p:nvSpPr>
-          <p:cNvPr id="3" name="James Wanueka circle"/>
+          <p:cNvPr id="3" name="James Wauneka circle"/>
           <p:cNvSpPr/>
           <p:nvPr/>
         </p:nvSpPr>
@@ -9070,7 +9070,7 @@
       </p:sp>
       <p:pic>
         <p:nvPicPr>
-          <p:cNvPr id="4" name="James Wanueka icon" descr="preencoded.png">    </p:cNvPr>
+          <p:cNvPr id="4" name="James Wauneka icon" descr="preencoded.png">    </p:cNvPr>
           <p:cNvPicPr>
             <a:picLocks noChangeAspect="1"/>
           </p:cNvPicPr>
@@ -9125,7 +9125,7 @@
                 <a:ea typeface="Cambria" pitchFamily="34" charset="-122"/>
                 <a:cs typeface="Cambria" pitchFamily="34" charset="-120"/>
               </a:rPr>
-              <a:t>James Wanueka</a:t>
+              <a:t>James Wauneka</a:t>
             </a:r>
             <a:endParaRPr lang="en-US" sz="2400" dirty="0"/>
           </a:p>

</xml_diff>